<commit_message>
Add data pipeline and experimental design diagrams; re-save Review 0 deck
</commit_message>
<xml_diff>
--- a/presentations/Mini_Project_Review_0.pptx
+++ b/presentations/Mini_Project_Review_0.pptx
@@ -1,39 +1,39 @@
 
 <file path=ppt/presentation.xml><?xml version="1.0" encoding="utf-8"?>
-<p:presentation xmlns:a="http://schemas.openxmlformats.org/drawingml/2006/main" xmlns:r="http://schemas.openxmlformats.org/officeDocument/2006/relationships" xmlns:mc="http://schemas.openxmlformats.org/markup-compatibility/2006" xmlns:mv="urn:schemas-microsoft-com:mac:vml" xmlns:p="http://schemas.openxmlformats.org/presentationml/2006/main" xmlns:c="http://schemas.openxmlformats.org/drawingml/2006/chart" xmlns:dgm="http://schemas.openxmlformats.org/drawingml/2006/diagram" xmlns:o="urn:schemas-microsoft-com:office:office" xmlns:v="urn:schemas-microsoft-com:vml" xmlns:pvml="urn:schemas-microsoft-com:office:powerpoint" xmlns:com="http://schemas.openxmlformats.org/drawingml/2006/compatibility" xmlns:p14="http://schemas.microsoft.com/office/powerpoint/2010/main" xmlns:p15="http://schemas.microsoft.com/office/powerpoint/2012/main" xmlns:ahyp="http://schemas.microsoft.com/office/drawing/2018/hyperlinkcolor" autoCompressPictures="0" strictFirstAndLastChars="0" saveSubsetFonts="1">
+<p:presentation xmlns:a="http://schemas.openxmlformats.org/drawingml/2006/main" xmlns:r="http://schemas.openxmlformats.org/officeDocument/2006/relationships" xmlns:p="http://schemas.openxmlformats.org/presentationml/2006/main" strictFirstAndLastChars="0" saveSubsetFonts="1" autoCompressPictures="0">
   <p:sldMasterIdLst>
-    <p:sldMasterId id="2147483648" r:id="rId5"/>
+    <p:sldMasterId id="2147483648" r:id="rId1"/>
   </p:sldMasterIdLst>
   <p:notesMasterIdLst>
-    <p:notesMasterId r:id="rId6"/>
+    <p:notesMasterId r:id="rId19"/>
   </p:notesMasterIdLst>
   <p:sldIdLst>
-    <p:sldId id="256" r:id="rId7"/>
-    <p:sldId id="258" r:id="rId9"/>
-    <p:sldId id="259" r:id="rId10"/>
-    <p:sldId id="260" r:id="rId11"/>
-    <p:sldId id="261" r:id="rId12"/>
-    <p:sldId id="262" r:id="rId13"/>
-    <p:sldId id="263" r:id="rId14"/>
-    <p:sldId id="264" r:id="rId15"/>
-    <p:sldId id="265" r:id="rId16"/>
-    <p:sldId id="266" r:id="rId17"/>
-    <p:sldId id="267" r:id="rId18"/>
-    <p:sldId id="268" r:id="rId19"/>
-    <p:sldId id="269" r:id="rId20"/>
-    <p:sldId id="270" r:id="rId21"/>
-    <p:sldId id="271" r:id="rId22"/>
-    <p:sldId id="272" r:id="rId23"/>
-    <p:sldId id="293" r:id="rId44"/>
+    <p:sldId id="256" r:id="rId2"/>
+    <p:sldId id="258" r:id="rId3"/>
+    <p:sldId id="259" r:id="rId4"/>
+    <p:sldId id="260" r:id="rId5"/>
+    <p:sldId id="261" r:id="rId6"/>
+    <p:sldId id="262" r:id="rId7"/>
+    <p:sldId id="263" r:id="rId8"/>
+    <p:sldId id="264" r:id="rId9"/>
+    <p:sldId id="265" r:id="rId10"/>
+    <p:sldId id="266" r:id="rId11"/>
+    <p:sldId id="267" r:id="rId12"/>
+    <p:sldId id="268" r:id="rId13"/>
+    <p:sldId id="269" r:id="rId14"/>
+    <p:sldId id="270" r:id="rId15"/>
+    <p:sldId id="271" r:id="rId16"/>
+    <p:sldId id="272" r:id="rId17"/>
+    <p:sldId id="293" r:id="rId18"/>
   </p:sldIdLst>
-  <p:sldSz cy="6858000" cx="9144000"/>
-  <p:notesSz cx="6954825" cy="9309100"/>
+  <p:sldSz cx="9144000" cy="6858000" type="screen4x3"/>
+  <p:notesSz cx="6954838" cy="9309100"/>
   <p:defaultTextStyle>
     <a:defPPr lvl="0">
       <a:defRPr lang="en-US"/>
     </a:defPPr>
-    <a:lvl1pPr defTabSz="457200" eaLnBrk="1" hangingPunct="1" latinLnBrk="0" lvl="0" marL="0" rtl="0" algn="l">
-      <a:defRPr kern="1200" sz="1800">
+    <a:lvl1pPr marL="0" lvl="0" algn="l" defTabSz="457200" rtl="0" eaLnBrk="1" latinLnBrk="0" hangingPunct="1">
+      <a:defRPr sz="1800" kern="1200">
         <a:solidFill>
           <a:schemeClr val="tx1"/>
         </a:solidFill>
@@ -42,8 +42,8 @@
         <a:cs typeface="+mn-cs"/>
       </a:defRPr>
     </a:lvl1pPr>
-    <a:lvl2pPr defTabSz="457200" eaLnBrk="1" hangingPunct="1" latinLnBrk="0" lvl="1" marL="457200" rtl="0" algn="l">
-      <a:defRPr kern="1200" sz="1800">
+    <a:lvl2pPr marL="457200" lvl="1" algn="l" defTabSz="457200" rtl="0" eaLnBrk="1" latinLnBrk="0" hangingPunct="1">
+      <a:defRPr sz="1800" kern="1200">
         <a:solidFill>
           <a:schemeClr val="tx1"/>
         </a:solidFill>
@@ -52,8 +52,8 @@
         <a:cs typeface="+mn-cs"/>
       </a:defRPr>
     </a:lvl2pPr>
-    <a:lvl3pPr defTabSz="457200" eaLnBrk="1" hangingPunct="1" latinLnBrk="0" lvl="2" marL="914400" rtl="0" algn="l">
-      <a:defRPr kern="1200" sz="1800">
+    <a:lvl3pPr marL="914400" lvl="2" algn="l" defTabSz="457200" rtl="0" eaLnBrk="1" latinLnBrk="0" hangingPunct="1">
+      <a:defRPr sz="1800" kern="1200">
         <a:solidFill>
           <a:schemeClr val="tx1"/>
         </a:solidFill>
@@ -62,8 +62,8 @@
         <a:cs typeface="+mn-cs"/>
       </a:defRPr>
     </a:lvl3pPr>
-    <a:lvl4pPr defTabSz="457200" eaLnBrk="1" hangingPunct="1" latinLnBrk="0" lvl="3" marL="1371600" rtl="0" algn="l">
-      <a:defRPr kern="1200" sz="1800">
+    <a:lvl4pPr marL="1371600" lvl="3" algn="l" defTabSz="457200" rtl="0" eaLnBrk="1" latinLnBrk="0" hangingPunct="1">
+      <a:defRPr sz="1800" kern="1200">
         <a:solidFill>
           <a:schemeClr val="tx1"/>
         </a:solidFill>
@@ -72,8 +72,8 @@
         <a:cs typeface="+mn-cs"/>
       </a:defRPr>
     </a:lvl4pPr>
-    <a:lvl5pPr defTabSz="457200" eaLnBrk="1" hangingPunct="1" latinLnBrk="0" lvl="4" marL="1828800" rtl="0" algn="l">
-      <a:defRPr kern="1200" sz="1800">
+    <a:lvl5pPr marL="1828800" lvl="4" algn="l" defTabSz="457200" rtl="0" eaLnBrk="1" latinLnBrk="0" hangingPunct="1">
+      <a:defRPr sz="1800" kern="1200">
         <a:solidFill>
           <a:schemeClr val="tx1"/>
         </a:solidFill>
@@ -82,8 +82,8 @@
         <a:cs typeface="+mn-cs"/>
       </a:defRPr>
     </a:lvl5pPr>
-    <a:lvl6pPr defTabSz="457200" eaLnBrk="1" hangingPunct="1" latinLnBrk="0" lvl="5" marL="2286000" rtl="0" algn="l">
-      <a:defRPr kern="1200" sz="1800">
+    <a:lvl6pPr marL="2286000" lvl="5" algn="l" defTabSz="457200" rtl="0" eaLnBrk="1" latinLnBrk="0" hangingPunct="1">
+      <a:defRPr sz="1800" kern="1200">
         <a:solidFill>
           <a:schemeClr val="tx1"/>
         </a:solidFill>
@@ -92,8 +92,8 @@
         <a:cs typeface="+mn-cs"/>
       </a:defRPr>
     </a:lvl6pPr>
-    <a:lvl7pPr defTabSz="457200" eaLnBrk="1" hangingPunct="1" latinLnBrk="0" lvl="6" marL="2743200" rtl="0" algn="l">
-      <a:defRPr kern="1200" sz="1800">
+    <a:lvl7pPr marL="2743200" lvl="6" algn="l" defTabSz="457200" rtl="0" eaLnBrk="1" latinLnBrk="0" hangingPunct="1">
+      <a:defRPr sz="1800" kern="1200">
         <a:solidFill>
           <a:schemeClr val="tx1"/>
         </a:solidFill>
@@ -102,8 +102,8 @@
         <a:cs typeface="+mn-cs"/>
       </a:defRPr>
     </a:lvl7pPr>
-    <a:lvl8pPr defTabSz="457200" eaLnBrk="1" hangingPunct="1" latinLnBrk="0" lvl="7" marL="3200400" rtl="0" algn="l">
-      <a:defRPr kern="1200" sz="1800">
+    <a:lvl8pPr marL="3200400" lvl="7" algn="l" defTabSz="457200" rtl="0" eaLnBrk="1" latinLnBrk="0" hangingPunct="1">
+      <a:defRPr sz="1800" kern="1200">
         <a:solidFill>
           <a:schemeClr val="tx1"/>
         </a:solidFill>
@@ -112,8 +112,8 @@
         <a:cs typeface="+mn-cs"/>
       </a:defRPr>
     </a:lvl8pPr>
-    <a:lvl9pPr defTabSz="457200" eaLnBrk="1" hangingPunct="1" latinLnBrk="0" lvl="8" marL="3657600" rtl="0" algn="l">
-      <a:defRPr kern="1200" sz="1800">
+    <a:lvl9pPr marL="3657600" lvl="8" algn="l" defTabSz="457200" rtl="0" eaLnBrk="1" latinLnBrk="0" hangingPunct="1">
+      <a:defRPr sz="1800" kern="1200">
         <a:solidFill>
           <a:schemeClr val="tx1"/>
         </a:solidFill>
@@ -125,7 +125,7 @@
   </p:defaultTextStyle>
   <p:extLst>
     <p:ext uri="{EFAFB233-063F-42B5-8137-9DF3F51BA10A}">
-      <p15:sldGuideLst>
+      <p15:sldGuideLst xmlns:p15="http://schemas.microsoft.com/office/powerpoint/2012/main">
         <p15:guide id="1" orient="horz" pos="2160">
           <p15:clr>
             <a:srgbClr val="A4A3A4"/>
@@ -140,94 +140,6 @@
     </p:ext>
   </p:extLst>
 </p:presentation>
-</file>
-
-<file path=ppt/presProps1.xml><?xml version="1.0" encoding="utf-8"?>
-<p:presentationPr xmlns:a="http://schemas.openxmlformats.org/drawingml/2006/main" xmlns:r="http://schemas.openxmlformats.org/officeDocument/2006/relationships" xmlns:mc="http://schemas.openxmlformats.org/markup-compatibility/2006" xmlns:mv="urn:schemas-microsoft-com:mac:vml" xmlns:p="http://schemas.openxmlformats.org/presentationml/2006/main" xmlns:c="http://schemas.openxmlformats.org/drawingml/2006/chart" xmlns:dgm="http://schemas.openxmlformats.org/drawingml/2006/diagram" xmlns:o="urn:schemas-microsoft-com:office:office" xmlns:v="urn:schemas-microsoft-com:vml" xmlns:pvml="urn:schemas-microsoft-com:office:powerpoint" xmlns:com="http://schemas.openxmlformats.org/drawingml/2006/compatibility" xmlns:p14="http://schemas.microsoft.com/office/powerpoint/2010/main" xmlns:p15="http://schemas.microsoft.com/office/powerpoint/2012/main" xmlns:ahyp="http://schemas.microsoft.com/office/drawing/2018/hyperlinkcolor"/>
-</file>
-
-<file path=ppt/tableStyles1.xml><?xml version="1.0" encoding="utf-8"?>
-<a:tblStyleLst xmlns:a="http://schemas.openxmlformats.org/drawingml/2006/main" xmlns:r="http://schemas.openxmlformats.org/officeDocument/2006/relationships" def="{90651C3A-4460-11DB-9652-00E08161165F}">
-  <a:tblStyle styleId="{5940675A-B579-460E-94D1-54222C63F5DA}" styleName="No Style, Table Grid">
-    <a:wholeTbl>
-      <a:tcTxStyle>
-        <a:fontRef idx="minor">
-          <a:scrgbClr b="0" g="0" r="0"/>
-        </a:fontRef>
-        <a:schemeClr val="tx1"/>
-      </a:tcTxStyle>
-      <a:tcStyle>
-        <a:tcBdr>
-          <a:left>
-            <a:ln cmpd="sng" w="12700">
-              <a:solidFill>
-                <a:schemeClr val="tx1"/>
-              </a:solidFill>
-            </a:ln>
-          </a:left>
-          <a:right>
-            <a:ln cmpd="sng" w="12700">
-              <a:solidFill>
-                <a:schemeClr val="tx1"/>
-              </a:solidFill>
-            </a:ln>
-          </a:right>
-          <a:top>
-            <a:ln cmpd="sng" w="12700">
-              <a:solidFill>
-                <a:schemeClr val="tx1"/>
-              </a:solidFill>
-            </a:ln>
-          </a:top>
-          <a:bottom>
-            <a:ln cmpd="sng" w="12700">
-              <a:solidFill>
-                <a:schemeClr val="tx1"/>
-              </a:solidFill>
-            </a:ln>
-          </a:bottom>
-          <a:insideH>
-            <a:ln cmpd="sng" w="12700">
-              <a:solidFill>
-                <a:schemeClr val="tx1"/>
-              </a:solidFill>
-            </a:ln>
-          </a:insideH>
-          <a:insideV>
-            <a:ln cmpd="sng" w="12700">
-              <a:solidFill>
-                <a:schemeClr val="tx1"/>
-              </a:solidFill>
-            </a:ln>
-          </a:insideV>
-        </a:tcBdr>
-        <a:fill>
-          <a:noFill/>
-        </a:fill>
-      </a:tcStyle>
-    </a:wholeTbl>
-  </a:tblStyle>
-</a:tblStyleLst>
-</file>
-
-<file path=ppt/viewProps1.xml><?xml version="1.0" encoding="utf-8"?>
-<p:viewPr xmlns:a="http://schemas.openxmlformats.org/drawingml/2006/main" xmlns:r="http://schemas.openxmlformats.org/officeDocument/2006/relationships" xmlns:mc="http://schemas.openxmlformats.org/markup-compatibility/2006" xmlns:mv="urn:schemas-microsoft-com:mac:vml" xmlns:p="http://schemas.openxmlformats.org/presentationml/2006/main" xmlns:c="http://schemas.openxmlformats.org/drawingml/2006/chart" xmlns:dgm="http://schemas.openxmlformats.org/drawingml/2006/diagram" xmlns:o="urn:schemas-microsoft-com:office:office" xmlns:v="urn:schemas-microsoft-com:vml" xmlns:pvml="urn:schemas-microsoft-com:office:powerpoint" xmlns:com="http://schemas.openxmlformats.org/drawingml/2006/compatibility" xmlns:p14="http://schemas.microsoft.com/office/powerpoint/2010/main" xmlns:p15="http://schemas.microsoft.com/office/powerpoint/2012/main" xmlns:ahyp="http://schemas.microsoft.com/office/drawing/2018/hyperlinkcolor" showComments="0">
-  <p:slideViewPr>
-    <p:cSldViewPr snapToGrid="0">
-      <p:cViewPr varScale="1">
-        <p:scale>
-          <a:sx n="100" d="100"/>
-          <a:sy n="100" d="100"/>
-        </p:scale>
-        <p:origin x="0" y="0"/>
-      </p:cViewPr>
-      <p:guideLst>
-        <p:guide pos="2160" orient="horz"/>
-        <p:guide pos="2880"/>
-      </p:guideLst>
-    </p:cSldViewPr>
-  </p:slideViewPr>
-</p:viewPr>
 </file>
 
 <file path=ppt/notesMasters/notesMaster1.xml><?xml version="1.0" encoding="utf-8"?>
@@ -313,7 +225,7 @@
             <a:fld id="{71B727E3-9991-4B0C-8167-23E35F3043C3}" type="datetimeFigureOut">
               <a:rPr lang="en-US" smtClean="0"/>
               <a:pPr/>
-              <a:t>8/8/2026</a:t>
+              <a:t>9/18/2026</a:t>
             </a:fld>
             <a:endParaRPr lang="en-US"/>
           </a:p>
@@ -582,7 +494,7 @@
 </file>
 
 <file path=ppt/notesSlides/notesSlide1.xml><?xml version="1.0" encoding="utf-8"?>
-<p:notes xmlns:a="http://schemas.openxmlformats.org/drawingml/2006/main" xmlns:p="http://schemas.openxmlformats.org/presentationml/2006/main" xmlns:r="http://schemas.openxmlformats.org/officeDocument/2006/relationships">
+<p:notes xmlns:a="http://schemas.openxmlformats.org/drawingml/2006/main" xmlns:r="http://schemas.openxmlformats.org/officeDocument/2006/relationships" xmlns:p="http://schemas.openxmlformats.org/presentationml/2006/main">
   <p:cSld>
     <p:spTree>
       <p:nvGrpSpPr>
@@ -602,7 +514,7 @@
         <p:nvSpPr>
           <p:cNvPr id="2" name="Slide Image Placeholder 1"/>
           <p:cNvSpPr>
-            <a:spLocks noGrp="1"/>
+            <a:spLocks noGrp="1" noRot="1" noChangeAspect="1"/>
           </p:cNvSpPr>
           <p:nvPr>
             <p:ph type="sldImg" idx="2"/>
@@ -617,7 +529,7 @@
             <a:spLocks noGrp="1"/>
           </p:cNvSpPr>
           <p:nvPr>
-            <p:ph type="body" idx="3" sz="quarter"/>
+            <p:ph type="body" sz="quarter" idx="3"/>
           </p:nvPr>
         </p:nvSpPr>
         <p:spPr/>
@@ -638,7 +550,7 @@
             <a:spLocks noGrp="1"/>
           </p:cNvSpPr>
           <p:nvPr>
-            <p:ph type="sldNum" idx="5" sz="quarter"/>
+            <p:ph type="sldNum" sz="quarter" idx="5"/>
           </p:nvPr>
         </p:nvSpPr>
         <p:spPr/>
@@ -783,7 +695,7 @@
             <a:fld id="{6C6A3A6F-B049-4A3C-A314-6C5DC6ABA413}" type="datetime1">
               <a:rPr lang="en-US" smtClean="0"/>
               <a:pPr/>
-              <a:t>8/8/2026</a:t>
+              <a:t>9/18/2026</a:t>
             </a:fld>
             <a:endParaRPr lang="en-US"/>
           </a:p>
@@ -955,7 +867,7 @@
             <a:fld id="{BE0F1400-0AF8-4881-9500-1BCE077EF02C}" type="datetime1">
               <a:rPr lang="en-US" smtClean="0"/>
               <a:pPr/>
-              <a:t>8/8/2026</a:t>
+              <a:t>9/18/2026</a:t>
             </a:fld>
             <a:endParaRPr lang="en-US"/>
           </a:p>
@@ -1137,7 +1049,7 @@
             <a:fld id="{5B520AC9-8025-43C3-9D7A-B30453D05E68}" type="datetime1">
               <a:rPr lang="en-US" smtClean="0"/>
               <a:pPr/>
-              <a:t>8/8/2026</a:t>
+              <a:t>9/18/2026</a:t>
             </a:fld>
             <a:endParaRPr lang="en-US"/>
           </a:p>
@@ -1309,7 +1221,7 @@
             <a:fld id="{880A0579-E4EA-4069-8E9E-A5661942CE83}" type="datetime1">
               <a:rPr lang="en-US" smtClean="0"/>
               <a:pPr/>
-              <a:t>8/8/2026</a:t>
+              <a:t>9/18/2026</a:t>
             </a:fld>
             <a:endParaRPr lang="en-US"/>
           </a:p>
@@ -1555,7 +1467,7 @@
             <a:fld id="{DCBAC4A0-A0AB-494A-9349-6940CE23F0BB}" type="datetime1">
               <a:rPr lang="en-US" smtClean="0"/>
               <a:pPr/>
-              <a:t>8/8/2026</a:t>
+              <a:t>9/18/2026</a:t>
             </a:fld>
             <a:endParaRPr lang="en-US"/>
           </a:p>
@@ -1789,7 +1701,7 @@
             <a:fld id="{8409F13F-E3C0-47E7-81E7-2D67CDFD97CE}" type="datetime1">
               <a:rPr lang="en-US" smtClean="0"/>
               <a:pPr/>
-              <a:t>8/8/2026</a:t>
+              <a:t>9/18/2026</a:t>
             </a:fld>
             <a:endParaRPr lang="en-US"/>
           </a:p>
@@ -2158,7 +2070,7 @@
             <a:fld id="{E2CB4F48-C21C-4E8E-AA43-BB8E3BD2F306}" type="datetime1">
               <a:rPr lang="en-US" smtClean="0"/>
               <a:pPr/>
-              <a:t>8/8/2026</a:t>
+              <a:t>9/18/2026</a:t>
             </a:fld>
             <a:endParaRPr lang="en-US"/>
           </a:p>
@@ -2278,7 +2190,7 @@
             <a:fld id="{9990D7BC-B940-4993-A11F-8FBB77BA204E}" type="datetime1">
               <a:rPr lang="en-US" smtClean="0"/>
               <a:pPr/>
-              <a:t>8/8/2026</a:t>
+              <a:t>9/18/2026</a:t>
             </a:fld>
             <a:endParaRPr lang="en-US"/>
           </a:p>
@@ -2375,7 +2287,7 @@
             <a:fld id="{F6094854-92A4-4BB6-9F1F-69BBC71788FF}" type="datetime1">
               <a:rPr lang="en-US" smtClean="0"/>
               <a:pPr/>
-              <a:t>8/8/2026</a:t>
+              <a:t>9/18/2026</a:t>
             </a:fld>
             <a:endParaRPr lang="en-US"/>
           </a:p>
@@ -2654,7 +2566,7 @@
             <a:fld id="{8CC6CBDC-D391-4FA9-8D6F-9BC119CA0B97}" type="datetime1">
               <a:rPr lang="en-US" smtClean="0"/>
               <a:pPr/>
-              <a:t>8/8/2026</a:t>
+              <a:t>9/18/2026</a:t>
             </a:fld>
             <a:endParaRPr lang="en-US"/>
           </a:p>
@@ -2913,7 +2825,7 @@
             <a:fld id="{129F212E-DE5B-4D49-B277-6F5AF26D6AF0}" type="datetime1">
               <a:rPr lang="en-US" smtClean="0"/>
               <a:pPr/>
-              <a:t>8/8/2026</a:t>
+              <a:t>9/18/2026</a:t>
             </a:fld>
             <a:endParaRPr lang="en-US"/>
           </a:p>
@@ -3128,7 +3040,7 @@
             <a:fld id="{505C9A0F-356B-4543-BBC4-6729314C25D3}" type="datetime1">
               <a:rPr lang="en-US" smtClean="0"/>
               <a:pPr/>
-              <a:t>8/8/2026</a:t>
+              <a:t>9/18/2026</a:t>
             </a:fld>
             <a:endParaRPr lang="en-US"/>
           </a:p>
@@ -3599,28 +3511,24 @@
           </a:bodyPr>
           <a:lstStyle/>
           <a:p>
-            <a:pPr/>
             <a:r>
               <a:rPr sz="1400" b="1"/>
               <a:t>Batch Members</a:t>
             </a:r>
           </a:p>
           <a:p>
-            <a:pPr/>
             <a:r>
               <a:rPr sz="1300" b="0"/>
               <a:t>P. Charan Sai (238W1A5447)</a:t>
             </a:r>
           </a:p>
           <a:p>
-            <a:pPr/>
             <a:r>
               <a:rPr sz="1300" b="0"/>
               <a:t>G. Karthik (248W5A5404)</a:t>
             </a:r>
           </a:p>
           <a:p>
-            <a:pPr/>
             <a:r>
               <a:rPr sz="1300" b="0"/>
               <a:t>P. Sanath (238W1A5446)</a:t>
@@ -3652,7 +3560,7 @@
           </a:prstGeom>
         </p:spPr>
         <p:txBody>
-          <a:bodyPr vert="horz" lIns="91440" tIns="45720" rIns="91440" bIns="45720" rtlCol="0" wrap="square">
+          <a:bodyPr vert="horz" wrap="square" lIns="91440" tIns="45720" rIns="91440" bIns="45720" rtlCol="0">
             <a:normAutofit/>
           </a:bodyPr>
           <a:lstStyle>
@@ -3820,21 +3728,18 @@
             </a:lvl9pPr>
           </a:lstStyle>
           <a:p>
-            <a:pPr/>
             <a:r>
               <a:rPr sz="1400" b="1"/>
               <a:t>Under the Guidance of</a:t>
             </a:r>
           </a:p>
           <a:p>
-            <a:pPr/>
             <a:r>
               <a:rPr sz="1300" b="0"/>
               <a:t>Mrs. K. Divya Kothapali</a:t>
             </a:r>
           </a:p>
           <a:p>
-            <a:pPr/>
             <a:r>
               <a:rPr sz="1200" b="0"/>
               <a:t>Assistant Professor</a:t>
@@ -3866,7 +3771,7 @@
           </a:prstGeom>
         </p:spPr>
         <p:txBody>
-          <a:bodyPr vert="horz" lIns="91440" tIns="45720" rIns="91440" bIns="45720" rtlCol="0" anchor="b" wrap="square">
+          <a:bodyPr vert="horz" wrap="square" lIns="91440" tIns="45720" rIns="91440" bIns="45720" rtlCol="0" anchor="b">
             <a:noAutofit/>
           </a:bodyPr>
           <a:lstStyle>
@@ -3889,21 +3794,18 @@
             </a:lvl1pPr>
           </a:lstStyle>
           <a:p>
-            <a:pPr/>
             <a:r>
               <a:rPr sz="1400" b="0"/>
               <a:t>23CS7552: B. Tech Mini Project (0th Review)</a:t>
             </a:r>
           </a:p>
           <a:p>
-            <a:pPr/>
             <a:r>
               <a:rPr sz="1300" b="0"/>
               <a:t>August 18, 2026</a:t>
             </a:r>
           </a:p>
           <a:p>
-            <a:pPr/>
             <a:r>
               <a:rPr sz="1300" b="0"/>
               <a:t>Batch No: __</a:t>
@@ -4146,7 +4048,7 @@
                 </a:solidFill>
                 <a:latin typeface="Calisto MT" panose="02040603050505030304" pitchFamily="18" charset="0"/>
               </a:rPr>
-              <a:t>6. Objectives</a:t>
+              <a:t>7. Scope</a:t>
             </a:r>
           </a:p>
         </p:txBody>
@@ -4169,97 +4071,91 @@
         </p:nvSpPr>
         <p:spPr>
           <a:xfrm>
-            <a:off x="358218" y="867265"/>
-            <a:ext cx="8314441" cy="5870705"/>
+            <a:off x="358218" y="1018094"/>
+            <a:ext cx="8314441" cy="5338257"/>
           </a:xfrm>
         </p:spPr>
         <p:txBody>
-          <a:bodyPr numCol="1" wrap="square">
+          <a:bodyPr wrap="square" numCol="1">
             <a:normAutofit/>
           </a:bodyPr>
           <a:lstStyle/>
           <a:p>
-            <a:pPr/>
-            <a:r>
-              <a:rPr sz="1600" b="1"/>
-              <a:t>O1 - Reproducible data foundation</a:t>
+            <a:r>
+              <a:rPr sz="1700" b="1"/>
+              <a:t>In scope</a:t>
             </a:r>
           </a:p>
           <a:p>
             <a:pPr lvl="1"/>
             <a:r>
-              <a:rPr sz="1400" b="0"/>
-              <a:t>Chromosome-split hg38 and Hi-C dataset at 5 kb, rebuildable from a tracked manifest</a:t>
-            </a:r>
-          </a:p>
-          <a:p>
-            <a:pPr/>
-            <a:r>
-              <a:rPr sz="1600" b="1"/>
-              <a:t>O2 - Sparse contact graph construction</a:t>
+              <a:rPr sz="1500" b="0"/>
+              <a:t>Human genome hg38; bulk Hi-C from 4DN and ENCODE</a:t>
             </a:r>
           </a:p>
           <a:p>
             <a:pPr lvl="1"/>
             <a:r>
-              <a:rPr sz="1400" b="0"/>
-              <a:t>640 kb regions as 128-node graphs, with target edges provably held out from the conditioning edges</a:t>
-            </a:r>
-          </a:p>
-          <a:p>
-            <a:pPr/>
-            <a:r>
-              <a:rPr sz="1600" b="1"/>
-              <a:t>O3 - Contact-biased sequence encoder</a:t>
+              <a:rPr sz="1500" b="0"/>
+              <a:t>5 kb contact resolution; 640 kb context (128 nodes x 5 kb)</a:t>
             </a:r>
           </a:p>
           <a:p>
             <a:pPr lvl="1"/>
             <a:r>
-              <a:rPr sz="1400" b="0"/>
-              <a:t>Bi-directional Mamba local encoder, contact-biased attention, structure dropout</a:t>
-            </a:r>
-          </a:p>
-          <a:p>
-            <a:pPr/>
-            <a:r>
-              <a:rPr sz="1600" b="1"/>
-              <a:t>O4 - Structure-aware pretraining</a:t>
+              <a:rPr sz="1500" b="0"/>
+              <a:t>2-3 cell lines, one fully held out; 20-40M parameters; DNA and Hi-C only</a:t>
             </a:r>
           </a:p>
           <a:p>
             <a:pPr lvl="1"/>
             <a:r>
-              <a:rPr sz="1400" b="0"/>
-              <a:t>Masked DNA modelling, distance-matched contrastive learning, contact prediction</a:t>
-            </a:r>
-          </a:p>
-          <a:p>
-            <a:pPr/>
-            <a:r>
-              <a:rPr sz="1600" b="1"/>
-              <a:t>O5 - Controlled evaluation</a:t>
+              <a:rPr sz="1500" b="0"/>
+              <a:t>Controlled comparison against our own matched baselines B0-B5</a:t>
+            </a:r>
+          </a:p>
+          <a:p>
+            <a:r>
+              <a:rPr sz="1700" b="1"/>
+              <a:t>Out of scope</a:t>
             </a:r>
           </a:p>
           <a:p>
             <a:pPr lvl="1"/>
             <a:r>
-              <a:rPr sz="1400" b="0"/>
-              <a:t>B0-B5 controls at matched parameters, data and steps; held-out chromosomes, held-out cell line, Hi-C-free inference</a:t>
-            </a:r>
-          </a:p>
-          <a:p>
-            <a:pPr/>
-            <a:r>
-              <a:rPr sz="1600" b="1"/>
-              <a:t>O6 - Biological interpretation</a:t>
+              <a:rPr sz="1500" b="0"/>
+              <a:t>Billion-parameter pretraining; million-base contexts</a:t>
             </a:r>
           </a:p>
           <a:p>
             <a:pPr lvl="1"/>
             <a:r>
-              <a:rPr sz="1400" b="0"/>
-              <a:t>Test whether high-attention contact anchors are enriched for CTCF motifs and overlap known loop anchors</a:t>
+              <a:rPr sz="1500" b="0"/>
+              <a:t>ATAC-seq, DNase-seq or CTCF tracks as model inputs (stretch goal only)</a:t>
+            </a:r>
+          </a:p>
+          <a:p>
+            <a:pPr lvl="1"/>
+            <a:r>
+              <a:rPr sz="1500" b="0"/>
+              <a:t>Single-cell Hi-C, cross-species transfer, variant-effect prediction (stretch)</a:t>
+            </a:r>
+          </a:p>
+          <a:p>
+            <a:r>
+              <a:rPr sz="1700" b="1"/>
+              <a:t>Claim discipline</a:t>
+            </a:r>
+          </a:p>
+          <a:p>
+            <a:pPr lvl="2"/>
+            <a:r>
+              <a:rPr sz="1300" b="0">
+                <a:solidFill>
+                  <a:srgbClr val="595959"/>
+                </a:solidFill>
+              </a:rPr>
+              <a:t>No claim of superiority over a published model unless task, data, split, metric, resolution and input setting all match. Published numbers are reported as context, never as a head-to-head result.</a:t>
             </a:r>
           </a:p>
         </p:txBody>
@@ -4307,7 +4203,7 @@
     </p:spTree>
     <p:extLst>
       <p:ext uri="{BB962C8B-B14F-4D97-AF65-F5344CB8AC3E}">
-        <p14:creationId xmlns:p14="http://schemas.microsoft.com/office/powerpoint/2010/main" val="441088729"/>
+        <p14:creationId xmlns:p14="http://schemas.microsoft.com/office/powerpoint/2010/main" val="2834744801"/>
       </p:ext>
     </p:extLst>
   </p:cSld>
@@ -4352,18 +4248,18 @@
         </p:nvSpPr>
         <p:spPr>
           <a:xfrm>
-            <a:off x="202676" y="120029"/>
-            <a:ext cx="8738648" cy="747237"/>
+            <a:off x="509047" y="270858"/>
+            <a:ext cx="8006303" cy="549273"/>
           </a:xfrm>
         </p:spPr>
         <p:txBody>
           <a:bodyPr>
-            <a:noAutofit/>
+            <a:normAutofit fontScale="90000"/>
           </a:bodyPr>
           <a:lstStyle/>
           <a:p>
             <a:r>
-              <a:rPr lang="en-US" sz="3000" b="1" dirty="0">
+              <a:rPr lang="en-US" sz="4000" b="1" dirty="0">
                 <a:solidFill>
                   <a:schemeClr val="accent2">
                     <a:lumMod val="50000"/>
@@ -4371,117 +4267,7 @@
                 </a:solidFill>
                 <a:latin typeface="Calisto MT" panose="02040603050505030304" pitchFamily="18" charset="0"/>
               </a:rPr>
-              <a:t>7. Scope</a:t>
-            </a:r>
-          </a:p>
-        </p:txBody>
-      </p:sp>
-      <p:sp>
-        <p:nvSpPr>
-          <p:cNvPr id="3" name="Content Placeholder 2">
-            <a:extLst>
-              <a:ext uri="{FF2B5EF4-FFF2-40B4-BE49-F238E27FC236}">
-                <a16:creationId xmlns:a16="http://schemas.microsoft.com/office/drawing/2014/main" id="{E5D502BE-F636-7D1D-85F0-BAFFD3E05E1C}"/>
-              </a:ext>
-            </a:extLst>
-          </p:cNvPr>
-          <p:cNvSpPr>
-            <a:spLocks noGrp="1"/>
-          </p:cNvSpPr>
-          <p:nvPr>
-            <p:ph idx="1"/>
-          </p:nvPr>
-        </p:nvSpPr>
-        <p:spPr>
-          <a:xfrm>
-            <a:off x="358218" y="1018094"/>
-            <a:ext cx="8314441" cy="5338257"/>
-          </a:xfrm>
-        </p:spPr>
-        <p:txBody>
-          <a:bodyPr numCol="1" wrap="square">
-            <a:normAutofit/>
-          </a:bodyPr>
-          <a:lstStyle/>
-          <a:p>
-            <a:pPr/>
-            <a:r>
-              <a:rPr sz="1700" b="1"/>
-              <a:t>In scope</a:t>
-            </a:r>
-          </a:p>
-          <a:p>
-            <a:pPr lvl="1"/>
-            <a:r>
-              <a:rPr sz="1500" b="0"/>
-              <a:t>Human genome hg38; bulk Hi-C from 4DN and ENCODE</a:t>
-            </a:r>
-          </a:p>
-          <a:p>
-            <a:pPr lvl="1"/>
-            <a:r>
-              <a:rPr sz="1500" b="0"/>
-              <a:t>5 kb contact resolution; 640 kb context (128 nodes x 5 kb)</a:t>
-            </a:r>
-          </a:p>
-          <a:p>
-            <a:pPr lvl="1"/>
-            <a:r>
-              <a:rPr sz="1500" b="0"/>
-              <a:t>2-3 cell lines, one fully held out; 20-40M parameters; DNA and Hi-C only</a:t>
-            </a:r>
-          </a:p>
-          <a:p>
-            <a:pPr lvl="1"/>
-            <a:r>
-              <a:rPr sz="1500" b="0"/>
-              <a:t>Controlled comparison against our own matched baselines B0-B5</a:t>
-            </a:r>
-          </a:p>
-          <a:p>
-            <a:pPr/>
-            <a:r>
-              <a:rPr sz="1700" b="1"/>
-              <a:t>Out of scope</a:t>
-            </a:r>
-          </a:p>
-          <a:p>
-            <a:pPr lvl="1"/>
-            <a:r>
-              <a:rPr sz="1500" b="0"/>
-              <a:t>Billion-parameter pretraining; million-base contexts</a:t>
-            </a:r>
-          </a:p>
-          <a:p>
-            <a:pPr lvl="1"/>
-            <a:r>
-              <a:rPr sz="1500" b="0"/>
-              <a:t>ATAC-seq, DNase-seq or CTCF tracks as model inputs (stretch goal only)</a:t>
-            </a:r>
-          </a:p>
-          <a:p>
-            <a:pPr lvl="1"/>
-            <a:r>
-              <a:rPr sz="1500" b="0"/>
-              <a:t>Single-cell Hi-C, cross-species transfer, variant-effect prediction (stretch)</a:t>
-            </a:r>
-          </a:p>
-          <a:p>
-            <a:pPr/>
-            <a:r>
-              <a:rPr sz="1700" b="1"/>
-              <a:t>Claim discipline</a:t>
-            </a:r>
-          </a:p>
-          <a:p>
-            <a:pPr lvl="2"/>
-            <a:r>
-              <a:rPr sz="1300" b="0">
-                <a:solidFill>
-                  <a:srgbClr val="595959"/>
-                </a:solidFill>
-              </a:rPr>
-              <a:t>No claim of superiority over a published model unless task, data, split, metric, resolution and input setting all match. Published numbers are reported as context, never as a head-to-head result.</a:t>
+              <a:t>8. Timeline Chart</a:t>
             </a:r>
           </a:p>
         </p:txBody>
@@ -4516,118 +4302,6 @@
               </a:rPr>
               <a:pPr/>
               <a:t>11</a:t>
-            </a:fld>
-            <a:endParaRPr lang="en-US" sz="1400" b="1" dirty="0">
-              <a:solidFill>
-                <a:schemeClr val="tx1"/>
-              </a:solidFill>
-              <a:latin typeface="Calisto MT" panose="02040603050505030304" pitchFamily="18" charset="0"/>
-            </a:endParaRPr>
-          </a:p>
-        </p:txBody>
-      </p:sp>
-    </p:spTree>
-    <p:extLst>
-      <p:ext uri="{BB962C8B-B14F-4D97-AF65-F5344CB8AC3E}">
-        <p14:creationId xmlns:p14="http://schemas.microsoft.com/office/powerpoint/2010/main" val="2834744801"/>
-      </p:ext>
-    </p:extLst>
-  </p:cSld>
-  <p:clrMapOvr>
-    <a:masterClrMapping/>
-  </p:clrMapOvr>
-</p:sld>
-</file>
-
-<file path=ppt/slides/slide12.xml><?xml version="1.0" encoding="utf-8"?>
-<p:sld xmlns:a="http://schemas.openxmlformats.org/drawingml/2006/main" xmlns:r="http://schemas.openxmlformats.org/officeDocument/2006/relationships" xmlns:p="http://schemas.openxmlformats.org/presentationml/2006/main">
-  <p:cSld>
-    <p:spTree>
-      <p:nvGrpSpPr>
-        <p:cNvPr id="1" name=""/>
-        <p:cNvGrpSpPr/>
-        <p:nvPr/>
-      </p:nvGrpSpPr>
-      <p:grpSpPr>
-        <a:xfrm>
-          <a:off x="0" y="0"/>
-          <a:ext cx="0" cy="0"/>
-          <a:chOff x="0" y="0"/>
-          <a:chExt cx="0" cy="0"/>
-        </a:xfrm>
-      </p:grpSpPr>
-      <p:sp>
-        <p:nvSpPr>
-          <p:cNvPr id="2" name="Title 1">
-            <a:extLst>
-              <a:ext uri="{FF2B5EF4-FFF2-40B4-BE49-F238E27FC236}">
-                <a16:creationId xmlns:a16="http://schemas.microsoft.com/office/drawing/2014/main" id="{5B738971-B764-E045-F92B-01E3322A0123}"/>
-              </a:ext>
-            </a:extLst>
-          </p:cNvPr>
-          <p:cNvSpPr>
-            <a:spLocks noGrp="1"/>
-          </p:cNvSpPr>
-          <p:nvPr>
-            <p:ph type="title"/>
-          </p:nvPr>
-        </p:nvSpPr>
-        <p:spPr>
-          <a:xfrm>
-            <a:off x="509047" y="270858"/>
-            <a:ext cx="8006303" cy="549273"/>
-          </a:xfrm>
-        </p:spPr>
-        <p:txBody>
-          <a:bodyPr>
-            <a:normAutofit fontScale="90000"/>
-          </a:bodyPr>
-          <a:lstStyle/>
-          <a:p>
-            <a:r>
-              <a:rPr lang="en-US" sz="4000" b="1" dirty="0">
-                <a:solidFill>
-                  <a:schemeClr val="accent2">
-                    <a:lumMod val="50000"/>
-                  </a:schemeClr>
-                </a:solidFill>
-                <a:latin typeface="Calisto MT" panose="02040603050505030304" pitchFamily="18" charset="0"/>
-              </a:rPr>
-              <a:t>8. Timeline Chart</a:t>
-            </a:r>
-          </a:p>
-        </p:txBody>
-      </p:sp>
-      <p:sp>
-        <p:nvSpPr>
-          <p:cNvPr id="7" name="Slide Number Placeholder 6">
-            <a:extLst>
-              <a:ext uri="{FF2B5EF4-FFF2-40B4-BE49-F238E27FC236}">
-                <a16:creationId xmlns:a16="http://schemas.microsoft.com/office/drawing/2014/main" id="{14F45621-8939-04E9-03B4-11AF180D5862}"/>
-              </a:ext>
-            </a:extLst>
-          </p:cNvPr>
-          <p:cNvSpPr>
-            <a:spLocks noGrp="1"/>
-          </p:cNvSpPr>
-          <p:nvPr>
-            <p:ph type="sldNum" sz="quarter" idx="12"/>
-          </p:nvPr>
-        </p:nvSpPr>
-        <p:spPr/>
-        <p:txBody>
-          <a:bodyPr/>
-          <a:lstStyle/>
-          <a:p>
-            <a:fld id="{D90542D4-23E8-43E0-BA8E-C972DA1A005D}" type="slidenum">
-              <a:rPr lang="en-US" sz="1400" b="1" smtClean="0">
-                <a:solidFill>
-                  <a:schemeClr val="tx1"/>
-                </a:solidFill>
-                <a:latin typeface="Calisto MT" panose="02040603050505030304" pitchFamily="18" charset="0"/>
-              </a:rPr>
-              <a:pPr/>
-              <a:t>12</a:t>
             </a:fld>
             <a:endParaRPr lang="en-US" sz="1400" b="1" dirty="0">
               <a:solidFill>
@@ -4690,10 +4364,34 @@
                 <a:tableStyleId>{5940675A-B579-460E-94D1-54222C63F5DA}</a:tableStyleId>
               </a:tblPr>
               <a:tblGrid>
-                <a:gridCol w="1026449"/>
-                <a:gridCol w="1026449"/>
-                <a:gridCol w="4721665"/>
-                <a:gridCol w="1231738"/>
+                <a:gridCol w="1026449">
+                  <a:extLst>
+                    <a:ext uri="{9D8B030D-6E8A-4147-A177-3AD203B41FA5}">
+                      <a16:colId xmlns:a16="http://schemas.microsoft.com/office/drawing/2014/main" val="20000"/>
+                    </a:ext>
+                  </a:extLst>
+                </a:gridCol>
+                <a:gridCol w="1026449">
+                  <a:extLst>
+                    <a:ext uri="{9D8B030D-6E8A-4147-A177-3AD203B41FA5}">
+                      <a16:colId xmlns:a16="http://schemas.microsoft.com/office/drawing/2014/main" val="20001"/>
+                    </a:ext>
+                  </a:extLst>
+                </a:gridCol>
+                <a:gridCol w="4721665">
+                  <a:extLst>
+                    <a:ext uri="{9D8B030D-6E8A-4147-A177-3AD203B41FA5}">
+                      <a16:colId xmlns:a16="http://schemas.microsoft.com/office/drawing/2014/main" val="20002"/>
+                    </a:ext>
+                  </a:extLst>
+                </a:gridCol>
+                <a:gridCol w="1231738">
+                  <a:extLst>
+                    <a:ext uri="{9D8B030D-6E8A-4147-A177-3AD203B41FA5}">
+                      <a16:colId xmlns:a16="http://schemas.microsoft.com/office/drawing/2014/main" val="20003"/>
+                    </a:ext>
+                  </a:extLst>
+                </a:gridCol>
               </a:tblGrid>
               <a:tr h="333756">
                 <a:tc>
@@ -4748,6 +4446,11 @@
                   </a:txBody>
                   <a:tcPr/>
                 </a:tc>
+                <a:extLst>
+                  <a:ext uri="{0D108BD9-81ED-4DB2-BD59-A6C34878D82A}">
+                    <a16:rowId xmlns:a16="http://schemas.microsoft.com/office/drawing/2014/main" val="10000"/>
+                  </a:ext>
+                </a:extLst>
               </a:tr>
               <a:tr h="333756">
                 <a:tc>
@@ -4802,6 +4505,11 @@
                   </a:txBody>
                   <a:tcPr/>
                 </a:tc>
+                <a:extLst>
+                  <a:ext uri="{0D108BD9-81ED-4DB2-BD59-A6C34878D82A}">
+                    <a16:rowId xmlns:a16="http://schemas.microsoft.com/office/drawing/2014/main" val="10001"/>
+                  </a:ext>
+                </a:extLst>
               </a:tr>
               <a:tr h="333756">
                 <a:tc>
@@ -4856,6 +4564,11 @@
                   </a:txBody>
                   <a:tcPr/>
                 </a:tc>
+                <a:extLst>
+                  <a:ext uri="{0D108BD9-81ED-4DB2-BD59-A6C34878D82A}">
+                    <a16:rowId xmlns:a16="http://schemas.microsoft.com/office/drawing/2014/main" val="10002"/>
+                  </a:ext>
+                </a:extLst>
               </a:tr>
               <a:tr h="333756">
                 <a:tc>
@@ -4910,6 +4623,11 @@
                   </a:txBody>
                   <a:tcPr/>
                 </a:tc>
+                <a:extLst>
+                  <a:ext uri="{0D108BD9-81ED-4DB2-BD59-A6C34878D82A}">
+                    <a16:rowId xmlns:a16="http://schemas.microsoft.com/office/drawing/2014/main" val="10003"/>
+                  </a:ext>
+                </a:extLst>
               </a:tr>
               <a:tr h="333756">
                 <a:tc>
@@ -4964,6 +4682,11 @@
                   </a:txBody>
                   <a:tcPr/>
                 </a:tc>
+                <a:extLst>
+                  <a:ext uri="{0D108BD9-81ED-4DB2-BD59-A6C34878D82A}">
+                    <a16:rowId xmlns:a16="http://schemas.microsoft.com/office/drawing/2014/main" val="10004"/>
+                  </a:ext>
+                </a:extLst>
               </a:tr>
               <a:tr h="333756">
                 <a:tc>
@@ -5018,6 +4741,11 @@
                   </a:txBody>
                   <a:tcPr/>
                 </a:tc>
+                <a:extLst>
+                  <a:ext uri="{0D108BD9-81ED-4DB2-BD59-A6C34878D82A}">
+                    <a16:rowId xmlns:a16="http://schemas.microsoft.com/office/drawing/2014/main" val="10005"/>
+                  </a:ext>
+                </a:extLst>
               </a:tr>
               <a:tr h="333756">
                 <a:tc>
@@ -5072,6 +4800,11 @@
                   </a:txBody>
                   <a:tcPr/>
                 </a:tc>
+                <a:extLst>
+                  <a:ext uri="{0D108BD9-81ED-4DB2-BD59-A6C34878D82A}">
+                    <a16:rowId xmlns:a16="http://schemas.microsoft.com/office/drawing/2014/main" val="10006"/>
+                  </a:ext>
+                </a:extLst>
               </a:tr>
               <a:tr h="333756">
                 <a:tc>
@@ -5126,6 +4859,11 @@
                   </a:txBody>
                   <a:tcPr/>
                 </a:tc>
+                <a:extLst>
+                  <a:ext uri="{0D108BD9-81ED-4DB2-BD59-A6C34878D82A}">
+                    <a16:rowId xmlns:a16="http://schemas.microsoft.com/office/drawing/2014/main" val="10007"/>
+                  </a:ext>
+                </a:extLst>
               </a:tr>
             </a:tbl>
           </a:graphicData>
@@ -5135,6 +4873,234 @@
     <p:extLst>
       <p:ext uri="{BB962C8B-B14F-4D97-AF65-F5344CB8AC3E}">
         <p14:creationId xmlns:p14="http://schemas.microsoft.com/office/powerpoint/2010/main" val="313617486"/>
+      </p:ext>
+    </p:extLst>
+  </p:cSld>
+  <p:clrMapOvr>
+    <a:masterClrMapping/>
+  </p:clrMapOvr>
+</p:sld>
+</file>
+
+<file path=ppt/slides/slide12.xml><?xml version="1.0" encoding="utf-8"?>
+<p:sld xmlns:a="http://schemas.openxmlformats.org/drawingml/2006/main" xmlns:r="http://schemas.openxmlformats.org/officeDocument/2006/relationships" xmlns:p="http://schemas.openxmlformats.org/presentationml/2006/main">
+  <p:cSld>
+    <p:spTree>
+      <p:nvGrpSpPr>
+        <p:cNvPr id="1" name=""/>
+        <p:cNvGrpSpPr/>
+        <p:nvPr/>
+      </p:nvGrpSpPr>
+      <p:grpSpPr>
+        <a:xfrm>
+          <a:off x="0" y="0"/>
+          <a:ext cx="0" cy="0"/>
+          <a:chOff x="0" y="0"/>
+          <a:chExt cx="0" cy="0"/>
+        </a:xfrm>
+      </p:grpSpPr>
+      <p:sp>
+        <p:nvSpPr>
+          <p:cNvPr id="2" name="Title 1">
+            <a:extLst>
+              <a:ext uri="{FF2B5EF4-FFF2-40B4-BE49-F238E27FC236}">
+                <a16:creationId xmlns:a16="http://schemas.microsoft.com/office/drawing/2014/main" id="{5B738971-B764-E045-F92B-01E3322A0123}"/>
+              </a:ext>
+            </a:extLst>
+          </p:cNvPr>
+          <p:cNvSpPr>
+            <a:spLocks noGrp="1"/>
+          </p:cNvSpPr>
+          <p:nvPr>
+            <p:ph type="title"/>
+          </p:nvPr>
+        </p:nvSpPr>
+        <p:spPr>
+          <a:xfrm>
+            <a:off x="202676" y="120029"/>
+            <a:ext cx="8738648" cy="747237"/>
+          </a:xfrm>
+        </p:spPr>
+        <p:txBody>
+          <a:bodyPr>
+            <a:noAutofit/>
+          </a:bodyPr>
+          <a:lstStyle/>
+          <a:p>
+            <a:r>
+              <a:rPr lang="en-US" sz="3000" b="1" dirty="0">
+                <a:solidFill>
+                  <a:schemeClr val="accent2">
+                    <a:lumMod val="50000"/>
+                  </a:schemeClr>
+                </a:solidFill>
+                <a:latin typeface="Calisto MT" panose="02040603050505030304" pitchFamily="18" charset="0"/>
+              </a:rPr>
+              <a:t>9. Introduction</a:t>
+            </a:r>
+          </a:p>
+        </p:txBody>
+      </p:sp>
+      <p:sp>
+        <p:nvSpPr>
+          <p:cNvPr id="3" name="Content Placeholder 2">
+            <a:extLst>
+              <a:ext uri="{FF2B5EF4-FFF2-40B4-BE49-F238E27FC236}">
+                <a16:creationId xmlns:a16="http://schemas.microsoft.com/office/drawing/2014/main" id="{E5D502BE-F636-7D1D-85F0-BAFFD3E05E1C}"/>
+              </a:ext>
+            </a:extLst>
+          </p:cNvPr>
+          <p:cNvSpPr>
+            <a:spLocks noGrp="1"/>
+          </p:cNvSpPr>
+          <p:nvPr>
+            <p:ph idx="1"/>
+          </p:nvPr>
+        </p:nvSpPr>
+        <p:spPr>
+          <a:xfrm>
+            <a:off x="202675" y="763571"/>
+            <a:ext cx="8738647" cy="5974399"/>
+          </a:xfrm>
+        </p:spPr>
+        <p:txBody>
+          <a:bodyPr wrap="square" numCol="1">
+            <a:normAutofit/>
+          </a:bodyPr>
+          <a:lstStyle/>
+          <a:p>
+            <a:r>
+              <a:rPr sz="1700" b="1" dirty="0"/>
+              <a:t>The biology</a:t>
+            </a:r>
+          </a:p>
+          <a:p>
+            <a:pPr lvl="1"/>
+            <a:r>
+              <a:rPr sz="1500" b="0" dirty="0"/>
+              <a:t>Human DNA is about 2 </a:t>
+            </a:r>
+            <a:r>
+              <a:rPr sz="1500" b="0" dirty="0" err="1"/>
+              <a:t>metres</a:t>
+            </a:r>
+            <a:r>
+              <a:rPr sz="1500" b="0" dirty="0"/>
+              <a:t> long and folds into a nucleus about 6 </a:t>
+            </a:r>
+            <a:r>
+              <a:rPr sz="1500" b="0" dirty="0" err="1"/>
+              <a:t>micrometres</a:t>
+            </a:r>
+            <a:r>
+              <a:rPr sz="1500" b="0" dirty="0"/>
+              <a:t> across. The folding is not random: it forms loops, domains and compartments.</a:t>
+            </a:r>
+          </a:p>
+          <a:p>
+            <a:pPr lvl="1"/>
+            <a:r>
+              <a:rPr sz="1500" b="0" dirty="0"/>
+              <a:t>An enhancer can regulate a gene a megabase away because folding brings them into physical proximity. Sequence adjacency and functional adjacency differ.</a:t>
+            </a:r>
+          </a:p>
+          <a:p>
+            <a:r>
+              <a:rPr sz="1700" b="1" dirty="0"/>
+              <a:t>The measurement</a:t>
+            </a:r>
+          </a:p>
+          <a:p>
+            <a:pPr lvl="1"/>
+            <a:r>
+              <a:rPr sz="1500" b="0" dirty="0"/>
+              <a:t>Hi-C sequences pairs of genomic fragments that were physically close, producing a contact matrix over genomic bins - the experimental readout of that folding.</a:t>
+            </a:r>
+          </a:p>
+          <a:p>
+            <a:r>
+              <a:rPr sz="1700" b="1" dirty="0"/>
+              <a:t>The modelling gap</a:t>
+            </a:r>
+          </a:p>
+          <a:p>
+            <a:pPr lvl="1"/>
+            <a:r>
+              <a:rPr sz="1500" b="0" dirty="0"/>
+              <a:t>Genomic language models read the genome as text. Attention over sequence position cannot know two distant windows are </a:t>
+            </a:r>
+            <a:r>
+              <a:rPr sz="1500" b="0" dirty="0" err="1"/>
+              <a:t>neighbours</a:t>
+            </a:r>
+            <a:r>
+              <a:rPr sz="1500" b="0" dirty="0"/>
+              <a:t> in space unless it is told.</a:t>
+            </a:r>
+          </a:p>
+          <a:p>
+            <a:r>
+              <a:rPr sz="1700" b="1" dirty="0"/>
+              <a:t>This project</a:t>
+            </a:r>
+          </a:p>
+          <a:p>
+            <a:pPr lvl="2"/>
+            <a:r>
+              <a:rPr sz="1300" b="0" dirty="0">
+                <a:solidFill>
+                  <a:srgbClr val="595959"/>
+                </a:solidFill>
+              </a:rPr>
+              <a:t>Tell it, during pretraining, and measure whether that changes what the encoder learns - with controls strong enough that a positive result means something.</a:t>
+            </a:r>
+          </a:p>
+        </p:txBody>
+      </p:sp>
+      <p:sp>
+        <p:nvSpPr>
+          <p:cNvPr id="7" name="Slide Number Placeholder 6">
+            <a:extLst>
+              <a:ext uri="{FF2B5EF4-FFF2-40B4-BE49-F238E27FC236}">
+                <a16:creationId xmlns:a16="http://schemas.microsoft.com/office/drawing/2014/main" id="{14F45621-8939-04E9-03B4-11AF180D5862}"/>
+              </a:ext>
+            </a:extLst>
+          </p:cNvPr>
+          <p:cNvSpPr>
+            <a:spLocks noGrp="1"/>
+          </p:cNvSpPr>
+          <p:nvPr>
+            <p:ph type="sldNum" sz="quarter" idx="12"/>
+          </p:nvPr>
+        </p:nvSpPr>
+        <p:spPr/>
+        <p:txBody>
+          <a:bodyPr/>
+          <a:lstStyle/>
+          <a:p>
+            <a:fld id="{D90542D4-23E8-43E0-BA8E-C972DA1A005D}" type="slidenum">
+              <a:rPr lang="en-US" sz="1400" b="1" smtClean="0">
+                <a:solidFill>
+                  <a:schemeClr val="tx1"/>
+                </a:solidFill>
+                <a:latin typeface="Calisto MT" panose="02040603050505030304" pitchFamily="18" charset="0"/>
+              </a:rPr>
+              <a:pPr/>
+              <a:t>12</a:t>
+            </a:fld>
+            <a:endParaRPr lang="en-US" sz="1400" b="1" dirty="0">
+              <a:solidFill>
+                <a:schemeClr val="tx1"/>
+              </a:solidFill>
+              <a:latin typeface="Calisto MT" panose="02040603050505030304" pitchFamily="18" charset="0"/>
+            </a:endParaRPr>
+          </a:p>
+        </p:txBody>
+      </p:sp>
+    </p:spTree>
+    <p:extLst>
+      <p:ext uri="{BB962C8B-B14F-4D97-AF65-F5344CB8AC3E}">
+        <p14:creationId xmlns:p14="http://schemas.microsoft.com/office/powerpoint/2010/main" val="1236915065"/>
       </p:ext>
     </p:extLst>
   </p:cSld>
@@ -5179,7 +5145,7 @@
         </p:nvSpPr>
         <p:spPr>
           <a:xfrm>
-            <a:off x="202676" y="120029"/>
+            <a:off x="202676" y="-51079"/>
             <a:ext cx="8738648" cy="747237"/>
           </a:xfrm>
         </p:spPr>
@@ -5198,7 +5164,7 @@
                 </a:solidFill>
                 <a:latin typeface="Calisto MT" panose="02040603050505030304" pitchFamily="18" charset="0"/>
               </a:rPr>
-              <a:t>9. Introduction</a:t>
+              <a:t>10. Study on Existing Technologies</a:t>
             </a:r>
           </a:p>
         </p:txBody>
@@ -5221,80 +5187,74 @@
         </p:nvSpPr>
         <p:spPr>
           <a:xfrm>
-            <a:off x="202675" y="763571"/>
-            <a:ext cx="8738647" cy="5974399"/>
+            <a:off x="358218" y="584462"/>
+            <a:ext cx="8314441" cy="6273538"/>
           </a:xfrm>
         </p:spPr>
         <p:txBody>
-          <a:bodyPr numCol="1" wrap="square">
-            <a:normAutofit/>
+          <a:bodyPr wrap="square" numCol="1">
+            <a:normAutofit fontScale="85000" lnSpcReduction="20000"/>
           </a:bodyPr>
           <a:lstStyle/>
           <a:p>
-            <a:pPr/>
-            <a:r>
-              <a:rPr sz="1700" b="1"/>
-              <a:t>The biology</a:t>
+            <a:r>
+              <a:rPr sz="1400" b="1"/>
+              <a:t>Title: Evo2HiC - a multimodal foundation model for integrative analysis of genome sequence and architecture [7]</a:t>
             </a:r>
           </a:p>
           <a:p>
             <a:pPr lvl="1"/>
             <a:r>
-              <a:rPr sz="1500" b="0"/>
-              <a:t>Human DNA is about 2 metres long and folds into a nucleus about 6 micrometres across. The folding is not random: it forms loops, domains and compartments.</a:t>
+              <a:rPr sz="1200" b="0"/>
+              <a:t>Venue: bioRxiv preprint, November 2025</a:t>
             </a:r>
           </a:p>
           <a:p>
             <a:pPr lvl="1"/>
             <a:r>
-              <a:rPr sz="1500" b="0"/>
-              <a:t>An enhancer can regulate a gene a megabase away because folding brings them into physical proximity. Sequence adjacency and functional adjacency differ.</a:t>
-            </a:r>
-          </a:p>
-          <a:p>
-            <a:pPr/>
-            <a:r>
-              <a:rPr sz="1700" b="1"/>
-              <a:t>The measurement</a:t>
+              <a:rPr sz="1200" b="0"/>
+              <a:t>Method: contrastive distillation of a frozen 7B-parameter Evo 2 into a 3.6M parameter CNN sequence encoder, aligned against Hi-C patch embeddings</a:t>
             </a:r>
           </a:p>
           <a:p>
             <a:pPr lvl="1"/>
             <a:r>
-              <a:rPr sz="1500" b="0"/>
-              <a:t>Hi-C sequences pairs of genomic fragments that were physically close, producing a contact matrix over genomic bins - the experimental readout of that folding.</a:t>
-            </a:r>
-          </a:p>
-          <a:p>
-            <a:pPr/>
-            <a:r>
-              <a:rPr sz="1700" b="1"/>
-              <a:t>The modelling gap</a:t>
+              <a:rPr sz="1200" b="0"/>
+              <a:t>Relevance: the closest precedent, and the reason this project cannot claim to be the first to use Hi-C in genomic representation learning</a:t>
             </a:r>
           </a:p>
           <a:p>
             <a:pPr lvl="1"/>
             <a:r>
-              <a:rPr sz="1500" b="0"/>
-              <a:t>Genomic language models read the genome as text. Attention over sequence position cannot know two distant windows are neighbours in space unless it is told.</a:t>
-            </a:r>
-          </a:p>
-          <a:p>
-            <a:pPr/>
-            <a:r>
-              <a:rPr sz="1700" b="1"/>
-              <a:t>This project</a:t>
-            </a:r>
-          </a:p>
-          <a:p>
-            <a:pPr lvl="2"/>
-            <a:r>
-              <a:rPr sz="1300" b="0">
-                <a:solidFill>
-                  <a:srgbClr val="595959"/>
-                </a:solidFill>
-              </a:rPr>
-              <a:t>Tell it, during pretraining, and measure whether that changes what the encoder learns - with controls strong enough that a positive result means something.</a:t>
+              <a:rPr sz="1200" b="0"/>
+              <a:t>Limitation we build on: the backbone stays frozen, and contacts never enter the encoder's own contextualisation</a:t>
+            </a:r>
+          </a:p>
+          <a:p>
+            <a:r>
+              <a:rPr sz="1400" b="1"/>
+              <a:t>Title: MIX-HIC - Multimodal 3D Genome Pre-training [6]</a:t>
+            </a:r>
+          </a:p>
+          <a:p>
+            <a:pPr lvl="1"/>
+            <a:r>
+              <a:rPr sz="1200" b="0"/>
+              <a:t>Venue: NeurIPS 2025 (arXiv:2504.09060)</a:t>
+            </a:r>
+          </a:p>
+          <a:p>
+            <a:pPr lvl="1"/>
+            <a:r>
+              <a:rPr sz="1200" b="0"/>
+              <a:t>Method: joint pretraining over Hi-C contact maps and epigenomic tracks, more than 1.2 million paired samples, 5 kb resolution, chromosome-level splits</a:t>
+            </a:r>
+          </a:p>
+          <a:p>
+            <a:pPr lvl="1"/>
+            <a:r>
+              <a:rPr sz="1200" b="0"/>
+              <a:t>Limitation we build on: raw DNA sequence is not an input; the authors name sequence integration as future work</a:t>
             </a:r>
           </a:p>
         </p:txBody>
@@ -5342,7 +5302,7 @@
     </p:spTree>
     <p:extLst>
       <p:ext uri="{BB962C8B-B14F-4D97-AF65-F5344CB8AC3E}">
-        <p14:creationId xmlns:p14="http://schemas.microsoft.com/office/powerpoint/2010/main" val="1236915065"/>
+        <p14:creationId xmlns:p14="http://schemas.microsoft.com/office/powerpoint/2010/main" val="1606825080"/>
       </p:ext>
     </p:extLst>
   </p:cSld>
@@ -5387,7 +5347,7 @@
         </p:nvSpPr>
         <p:spPr>
           <a:xfrm>
-            <a:off x="202676" y="-51079"/>
+            <a:off x="202676" y="82320"/>
             <a:ext cx="8738648" cy="747237"/>
           </a:xfrm>
         </p:spPr>
@@ -5429,76 +5389,77 @@
         </p:nvSpPr>
         <p:spPr>
           <a:xfrm>
-            <a:off x="358218" y="584462"/>
-            <a:ext cx="8314441" cy="6273538"/>
+            <a:off x="202675" y="829558"/>
+            <a:ext cx="8649093" cy="5891917"/>
           </a:xfrm>
         </p:spPr>
         <p:txBody>
-          <a:bodyPr numCol="1" wrap="square">
-            <a:normAutofit fontScale="85000" lnSpcReduction="20000"/>
+          <a:bodyPr wrap="square" numCol="1">
+            <a:normAutofit/>
           </a:bodyPr>
           <a:lstStyle/>
           <a:p>
-            <a:pPr/>
-            <a:r>
-              <a:rPr sz="1400" b="1"/>
-              <a:t>Title: Evo2HiC - a multimodal foundation model for integrative analysis of genome sequence and architecture [7]</a:t>
+            <a:r>
+              <a:rPr sz="1500" b="1"/>
+              <a:t>Three families of prior work</a:t>
             </a:r>
           </a:p>
           <a:p>
             <a:pPr lvl="1"/>
             <a:r>
-              <a:rPr sz="1200" b="0"/>
-              <a:t>Venue: bioRxiv preprint, November 2025</a:t>
+              <a:rPr sz="1300" b="0"/>
+              <a:t>Sequence-to-structure predictors - Akita, C.Origami, EPCOT. Sequence in, contact map out. Hi-C is the prediction target.</a:t>
             </a:r>
           </a:p>
           <a:p>
             <a:pPr lvl="1"/>
             <a:r>
-              <a:rPr sz="1200" b="0"/>
-              <a:t>Method: contrastive distillation of a frozen 7B-parameter Evo 2 into a 3.6M parameter CNN sequence encoder, aligned against Hi-C patch embeddings</a:t>
+              <a:rPr sz="1300" b="0"/>
+              <a:t>Hi-C representation models - HiCFoundation, MIX-HIC. Hi-C in, Hi-C representation out. DNA sequence absent or secondary.</a:t>
             </a:r>
           </a:p>
           <a:p>
             <a:pPr lvl="1"/>
             <a:r>
-              <a:rPr sz="1200" b="0"/>
-              <a:t>Relevance: the closest precedent, and the reason this project cannot claim to be the first to use Hi-C in genomic representation learning</a:t>
+              <a:rPr sz="1300" b="0"/>
+              <a:t>Sequence foundation models - Caduceus, HyenaDNA, Evo 2. Long-range sequence modelling with no structural signal.</a:t>
+            </a:r>
+          </a:p>
+          <a:p>
+            <a:r>
+              <a:rPr sz="1500" b="1"/>
+              <a:t>What the field has already settled</a:t>
             </a:r>
           </a:p>
           <a:p>
             <a:pPr lvl="1"/>
             <a:r>
-              <a:rPr sz="1200" b="0"/>
-              <a:t>Limitation we build on: the backbone stays frozen, and contacts never enter the encoder's own contextualisation</a:t>
-            </a:r>
-          </a:p>
-          <a:p>
-            <a:pPr/>
-            <a:r>
-              <a:rPr sz="1400" b="1"/>
-              <a:t>Title: MIX-HIC - Multimodal 3D Genome Pre-training [6]</a:t>
+              <a:rPr sz="1300" b="0"/>
+              <a:t>Hi-C can be predicted from sequence, and Hi-C maps can be pretrained on</a:t>
             </a:r>
           </a:p>
           <a:p>
             <a:pPr lvl="1"/>
             <a:r>
-              <a:rPr sz="1200" b="0"/>
-              <a:t>Venue: NeurIPS 2025 (arXiv:2504.09060)</a:t>
-            </a:r>
-          </a:p>
-          <a:p>
-            <a:pPr lvl="1"/>
-            <a:r>
-              <a:rPr sz="1200" b="0"/>
-              <a:t>Method: joint pretraining over Hi-C contact maps and epigenomic tracks, more than 1.2 million paired samples, 5 kb resolution, chromosome-level splits</a:t>
-            </a:r>
-          </a:p>
-          <a:p>
-            <a:pPr lvl="1"/>
-            <a:r>
-              <a:rPr sz="1200" b="0"/>
-              <a:t>Limitation we build on: raw DNA sequence is not an input; the authors name sequence integration as future work</a:t>
+              <a:rPr sz="1300" b="0"/>
+              <a:t>Hi-C can shape a sequence encoder by distillation (Evo2HiC)</a:t>
+            </a:r>
+          </a:p>
+          <a:p>
+            <a:r>
+              <a:rPr sz="1500" b="1"/>
+              <a:t>What this means for our claim</a:t>
+            </a:r>
+          </a:p>
+          <a:p>
+            <a:pPr lvl="2"/>
+            <a:r>
+              <a:rPr sz="1100" b="0">
+                <a:solidFill>
+                  <a:srgbClr val="595959"/>
+                </a:solidFill>
+              </a:rPr>
+              <a:t>"First to use Hi-C in a genomic foundation model" is false and must not be claimed. The defensible contribution is the mechanism and the controls that isolate it.</a:t>
             </a:r>
           </a:p>
         </p:txBody>
@@ -5546,7 +5507,7 @@
     </p:spTree>
     <p:extLst>
       <p:ext uri="{BB962C8B-B14F-4D97-AF65-F5344CB8AC3E}">
-        <p14:creationId xmlns:p14="http://schemas.microsoft.com/office/powerpoint/2010/main" val="1606825080"/>
+        <p14:creationId xmlns:p14="http://schemas.microsoft.com/office/powerpoint/2010/main" val="1115534737"/>
       </p:ext>
     </p:extLst>
   </p:cSld>
@@ -5591,7 +5552,7 @@
         </p:nvSpPr>
         <p:spPr>
           <a:xfrm>
-            <a:off x="202676" y="82320"/>
+            <a:off x="202676" y="-42585"/>
             <a:ext cx="8738648" cy="747237"/>
           </a:xfrm>
         </p:spPr>
@@ -5611,102 +5572,6 @@
                 <a:latin typeface="Calisto MT" panose="02040603050505030304" pitchFamily="18" charset="0"/>
               </a:rPr>
               <a:t>10. Study on Existing Technologies</a:t>
-            </a:r>
-          </a:p>
-        </p:txBody>
-      </p:sp>
-      <p:sp>
-        <p:nvSpPr>
-          <p:cNvPr id="3" name="Content Placeholder 2">
-            <a:extLst>
-              <a:ext uri="{FF2B5EF4-FFF2-40B4-BE49-F238E27FC236}">
-                <a16:creationId xmlns:a16="http://schemas.microsoft.com/office/drawing/2014/main" id="{E5D502BE-F636-7D1D-85F0-BAFFD3E05E1C}"/>
-              </a:ext>
-            </a:extLst>
-          </p:cNvPr>
-          <p:cNvSpPr>
-            <a:spLocks noGrp="1"/>
-          </p:cNvSpPr>
-          <p:nvPr>
-            <p:ph idx="1"/>
-          </p:nvPr>
-        </p:nvSpPr>
-        <p:spPr>
-          <a:xfrm>
-            <a:off x="202675" y="829558"/>
-            <a:ext cx="8649093" cy="5891917"/>
-          </a:xfrm>
-        </p:spPr>
-        <p:txBody>
-          <a:bodyPr numCol="1" wrap="square">
-            <a:normAutofit/>
-          </a:bodyPr>
-          <a:lstStyle/>
-          <a:p>
-            <a:pPr/>
-            <a:r>
-              <a:rPr sz="1500" b="1"/>
-              <a:t>Three families of prior work</a:t>
-            </a:r>
-          </a:p>
-          <a:p>
-            <a:pPr lvl="1"/>
-            <a:r>
-              <a:rPr sz="1300" b="0"/>
-              <a:t>Sequence-to-structure predictors - Akita, C.Origami, EPCOT. Sequence in, contact map out. Hi-C is the prediction target.</a:t>
-            </a:r>
-          </a:p>
-          <a:p>
-            <a:pPr lvl="1"/>
-            <a:r>
-              <a:rPr sz="1300" b="0"/>
-              <a:t>Hi-C representation models - HiCFoundation, MIX-HIC. Hi-C in, Hi-C representation out. DNA sequence absent or secondary.</a:t>
-            </a:r>
-          </a:p>
-          <a:p>
-            <a:pPr lvl="1"/>
-            <a:r>
-              <a:rPr sz="1300" b="0"/>
-              <a:t>Sequence foundation models - Caduceus, HyenaDNA, Evo 2. Long-range sequence modelling with no structural signal.</a:t>
-            </a:r>
-          </a:p>
-          <a:p>
-            <a:pPr/>
-            <a:r>
-              <a:rPr sz="1500" b="1"/>
-              <a:t>What the field has already settled</a:t>
-            </a:r>
-          </a:p>
-          <a:p>
-            <a:pPr lvl="1"/>
-            <a:r>
-              <a:rPr sz="1300" b="0"/>
-              <a:t>Hi-C can be predicted from sequence, and Hi-C maps can be pretrained on</a:t>
-            </a:r>
-          </a:p>
-          <a:p>
-            <a:pPr lvl="1"/>
-            <a:r>
-              <a:rPr sz="1300" b="0"/>
-              <a:t>Hi-C can shape a sequence encoder by distillation (Evo2HiC)</a:t>
-            </a:r>
-          </a:p>
-          <a:p>
-            <a:pPr/>
-            <a:r>
-              <a:rPr sz="1500" b="1"/>
-              <a:t>What this means for our claim</a:t>
-            </a:r>
-          </a:p>
-          <a:p>
-            <a:pPr lvl="2"/>
-            <a:r>
-              <a:rPr sz="1100" b="0">
-                <a:solidFill>
-                  <a:srgbClr val="595959"/>
-                </a:solidFill>
-              </a:rPr>
-              <a:t>"First to use Hi-C in a genomic foundation model" is false and must not be claimed. The defensible contribution is the mechanism and the controls that isolate it.</a:t>
             </a:r>
           </a:p>
         </p:txBody>
@@ -5751,118 +5616,6 @@
           </a:p>
         </p:txBody>
       </p:sp>
-    </p:spTree>
-    <p:extLst>
-      <p:ext uri="{BB962C8B-B14F-4D97-AF65-F5344CB8AC3E}">
-        <p14:creationId xmlns:p14="http://schemas.microsoft.com/office/powerpoint/2010/main" val="1115534737"/>
-      </p:ext>
-    </p:extLst>
-  </p:cSld>
-  <p:clrMapOvr>
-    <a:masterClrMapping/>
-  </p:clrMapOvr>
-</p:sld>
-</file>
-
-<file path=ppt/slides/slide16.xml><?xml version="1.0" encoding="utf-8"?>
-<p:sld xmlns:a="http://schemas.openxmlformats.org/drawingml/2006/main" xmlns:r="http://schemas.openxmlformats.org/officeDocument/2006/relationships" xmlns:p="http://schemas.openxmlformats.org/presentationml/2006/main">
-  <p:cSld>
-    <p:spTree>
-      <p:nvGrpSpPr>
-        <p:cNvPr id="1" name=""/>
-        <p:cNvGrpSpPr/>
-        <p:nvPr/>
-      </p:nvGrpSpPr>
-      <p:grpSpPr>
-        <a:xfrm>
-          <a:off x="0" y="0"/>
-          <a:ext cx="0" cy="0"/>
-          <a:chOff x="0" y="0"/>
-          <a:chExt cx="0" cy="0"/>
-        </a:xfrm>
-      </p:grpSpPr>
-      <p:sp>
-        <p:nvSpPr>
-          <p:cNvPr id="2" name="Title 1">
-            <a:extLst>
-              <a:ext uri="{FF2B5EF4-FFF2-40B4-BE49-F238E27FC236}">
-                <a16:creationId xmlns:a16="http://schemas.microsoft.com/office/drawing/2014/main" id="{5B738971-B764-E045-F92B-01E3322A0123}"/>
-              </a:ext>
-            </a:extLst>
-          </p:cNvPr>
-          <p:cNvSpPr>
-            <a:spLocks noGrp="1"/>
-          </p:cNvSpPr>
-          <p:nvPr>
-            <p:ph type="title"/>
-          </p:nvPr>
-        </p:nvSpPr>
-        <p:spPr>
-          <a:xfrm>
-            <a:off x="202676" y="-42585"/>
-            <a:ext cx="8738648" cy="747237"/>
-          </a:xfrm>
-        </p:spPr>
-        <p:txBody>
-          <a:bodyPr>
-            <a:noAutofit/>
-          </a:bodyPr>
-          <a:lstStyle/>
-          <a:p>
-            <a:r>
-              <a:rPr lang="en-US" sz="3000" b="1" dirty="0">
-                <a:solidFill>
-                  <a:schemeClr val="accent2">
-                    <a:lumMod val="50000"/>
-                  </a:schemeClr>
-                </a:solidFill>
-                <a:latin typeface="Calisto MT" panose="02040603050505030304" pitchFamily="18" charset="0"/>
-              </a:rPr>
-              <a:t>10. Study on Existing Technologies</a:t>
-            </a:r>
-          </a:p>
-        </p:txBody>
-      </p:sp>
-      <p:sp>
-        <p:nvSpPr>
-          <p:cNvPr id="7" name="Slide Number Placeholder 6">
-            <a:extLst>
-              <a:ext uri="{FF2B5EF4-FFF2-40B4-BE49-F238E27FC236}">
-                <a16:creationId xmlns:a16="http://schemas.microsoft.com/office/drawing/2014/main" id="{14F45621-8939-04E9-03B4-11AF180D5862}"/>
-              </a:ext>
-            </a:extLst>
-          </p:cNvPr>
-          <p:cNvSpPr>
-            <a:spLocks noGrp="1"/>
-          </p:cNvSpPr>
-          <p:nvPr>
-            <p:ph type="sldNum" sz="quarter" idx="12"/>
-          </p:nvPr>
-        </p:nvSpPr>
-        <p:spPr/>
-        <p:txBody>
-          <a:bodyPr/>
-          <a:lstStyle/>
-          <a:p>
-            <a:fld id="{D90542D4-23E8-43E0-BA8E-C972DA1A005D}" type="slidenum">
-              <a:rPr lang="en-US" sz="1400" b="1" smtClean="0">
-                <a:solidFill>
-                  <a:schemeClr val="tx1"/>
-                </a:solidFill>
-                <a:latin typeface="Calisto MT" panose="02040603050505030304" pitchFamily="18" charset="0"/>
-              </a:rPr>
-              <a:pPr/>
-              <a:t>16</a:t>
-            </a:fld>
-            <a:endParaRPr lang="en-US" sz="1400" b="1" dirty="0">
-              <a:solidFill>
-                <a:schemeClr val="tx1"/>
-              </a:solidFill>
-              <a:latin typeface="Calisto MT" panose="02040603050505030304" pitchFamily="18" charset="0"/>
-            </a:endParaRPr>
-          </a:p>
-        </p:txBody>
-      </p:sp>
       <p:sp>
         <p:nvSpPr>
           <p:cNvPr id="8" name="TextBox 7"/>
@@ -5902,11 +5655,17 @@
           <p:cNvGraphicFramePr>
             <a:graphicFrameLocks noGrp="1"/>
           </p:cNvGraphicFramePr>
-          <p:nvPr/>
+          <p:nvPr>
+            <p:extLst>
+              <p:ext uri="{D42A27DB-BD31-4B8C-83A1-F6EECF244321}">
+                <p14:modId xmlns:p14="http://schemas.microsoft.com/office/powerpoint/2010/main" val="2572465223"/>
+              </p:ext>
+            </p:extLst>
+          </p:nvPr>
         </p:nvGraphicFramePr>
         <p:xfrm>
           <a:off x="202675" y="968510"/>
-          <a:ext cx="8649091" cy="2670048"/>
+          <a:ext cx="8649091" cy="2982468"/>
         </p:xfrm>
         <a:graphic>
           <a:graphicData uri="http://schemas.openxmlformats.org/drawingml/2006/table">
@@ -5915,10 +5674,34 @@
                 <a:tableStyleId>{5940675A-B579-460E-94D1-54222C63F5DA}</a:tableStyleId>
               </a:tblPr>
               <a:tblGrid>
-                <a:gridCol w="1132619"/>
-                <a:gridCol w="1441515"/>
-                <a:gridCol w="2883030"/>
-                <a:gridCol w="3191927"/>
+                <a:gridCol w="1132619">
+                  <a:extLst>
+                    <a:ext uri="{9D8B030D-6E8A-4147-A177-3AD203B41FA5}">
+                      <a16:colId xmlns:a16="http://schemas.microsoft.com/office/drawing/2014/main" val="20000"/>
+                    </a:ext>
+                  </a:extLst>
+                </a:gridCol>
+                <a:gridCol w="1441515">
+                  <a:extLst>
+                    <a:ext uri="{9D8B030D-6E8A-4147-A177-3AD203B41FA5}">
+                      <a16:colId xmlns:a16="http://schemas.microsoft.com/office/drawing/2014/main" val="20001"/>
+                    </a:ext>
+                  </a:extLst>
+                </a:gridCol>
+                <a:gridCol w="2883030">
+                  <a:extLst>
+                    <a:ext uri="{9D8B030D-6E8A-4147-A177-3AD203B41FA5}">
+                      <a16:colId xmlns:a16="http://schemas.microsoft.com/office/drawing/2014/main" val="20002"/>
+                    </a:ext>
+                  </a:extLst>
+                </a:gridCol>
+                <a:gridCol w="3191927">
+                  <a:extLst>
+                    <a:ext uri="{9D8B030D-6E8A-4147-A177-3AD203B41FA5}">
+                      <a16:colId xmlns:a16="http://schemas.microsoft.com/office/drawing/2014/main" val="20003"/>
+                    </a:ext>
+                  </a:extLst>
+                </a:gridCol>
               </a:tblGrid>
               <a:tr h="333756">
                 <a:tc>
@@ -5927,9 +5710,14 @@
                     <a:lstStyle/>
                     <a:p>
                       <a:r>
-                        <a:rPr sz="1000" b="1"/>
+                        <a:rPr sz="1000" b="1" dirty="0"/>
                         <a:t>Model</a:t>
                       </a:r>
+                      <a:r>
+                        <a:rPr lang="en-IN" sz="1000" b="1" dirty="0"/>
+                        <a:t> </a:t>
+                      </a:r>
+                      <a:endParaRPr sz="1000" b="1" dirty="0"/>
                     </a:p>
                   </a:txBody>
                   <a:tcPr/>
@@ -5973,6 +5761,11 @@
                   </a:txBody>
                   <a:tcPr/>
                 </a:tc>
+                <a:extLst>
+                  <a:ext uri="{0D108BD9-81ED-4DB2-BD59-A6C34878D82A}">
+                    <a16:rowId xmlns:a16="http://schemas.microsoft.com/office/drawing/2014/main" val="10000"/>
+                  </a:ext>
+                </a:extLst>
               </a:tr>
               <a:tr h="333756">
                 <a:tc>
@@ -6027,6 +5820,11 @@
                   </a:txBody>
                   <a:tcPr/>
                 </a:tc>
+                <a:extLst>
+                  <a:ext uri="{0D108BD9-81ED-4DB2-BD59-A6C34878D82A}">
+                    <a16:rowId xmlns:a16="http://schemas.microsoft.com/office/drawing/2014/main" val="10001"/>
+                  </a:ext>
+                </a:extLst>
               </a:tr>
               <a:tr h="333756">
                 <a:tc>
@@ -6081,6 +5879,11 @@
                   </a:txBody>
                   <a:tcPr/>
                 </a:tc>
+                <a:extLst>
+                  <a:ext uri="{0D108BD9-81ED-4DB2-BD59-A6C34878D82A}">
+                    <a16:rowId xmlns:a16="http://schemas.microsoft.com/office/drawing/2014/main" val="10002"/>
+                  </a:ext>
+                </a:extLst>
               </a:tr>
               <a:tr h="333756">
                 <a:tc>
@@ -6135,6 +5938,11 @@
                   </a:txBody>
                   <a:tcPr/>
                 </a:tc>
+                <a:extLst>
+                  <a:ext uri="{0D108BD9-81ED-4DB2-BD59-A6C34878D82A}">
+                    <a16:rowId xmlns:a16="http://schemas.microsoft.com/office/drawing/2014/main" val="10003"/>
+                  </a:ext>
+                </a:extLst>
               </a:tr>
               <a:tr h="333756">
                 <a:tc>
@@ -6189,6 +5997,11 @@
                   </a:txBody>
                   <a:tcPr/>
                 </a:tc>
+                <a:extLst>
+                  <a:ext uri="{0D108BD9-81ED-4DB2-BD59-A6C34878D82A}">
+                    <a16:rowId xmlns:a16="http://schemas.microsoft.com/office/drawing/2014/main" val="10004"/>
+                  </a:ext>
+                </a:extLst>
               </a:tr>
               <a:tr h="333756">
                 <a:tc>
@@ -6243,6 +6056,11 @@
                   </a:txBody>
                   <a:tcPr/>
                 </a:tc>
+                <a:extLst>
+                  <a:ext uri="{0D108BD9-81ED-4DB2-BD59-A6C34878D82A}">
+                    <a16:rowId xmlns:a16="http://schemas.microsoft.com/office/drawing/2014/main" val="10005"/>
+                  </a:ext>
+                </a:extLst>
               </a:tr>
               <a:tr h="333756">
                 <a:tc>
@@ -6297,6 +6115,11 @@
                   </a:txBody>
                   <a:tcPr/>
                 </a:tc>
+                <a:extLst>
+                  <a:ext uri="{0D108BD9-81ED-4DB2-BD59-A6C34878D82A}">
+                    <a16:rowId xmlns:a16="http://schemas.microsoft.com/office/drawing/2014/main" val="10006"/>
+                  </a:ext>
+                </a:extLst>
               </a:tr>
               <a:tr h="333756">
                 <a:tc>
@@ -6344,13 +6167,23 @@
                     <a:lstStyle/>
                     <a:p>
                       <a:r>
-                        <a:rPr sz="1000" b="0"/>
-                        <a:t>Closest precedent; frozen backbone, contacts never enter contextualisation</a:t>
+                        <a:rPr sz="1000" b="0" dirty="0"/>
+                        <a:t>Closest precedent; frozen backbone, contacts never enter </a:t>
                       </a:r>
+                      <a:r>
+                        <a:rPr sz="1000" b="0" dirty="0" err="1"/>
+                        <a:t>contextualisation</a:t>
+                      </a:r>
+                      <a:endParaRPr sz="1000" b="0" dirty="0"/>
                     </a:p>
                   </a:txBody>
                   <a:tcPr/>
                 </a:tc>
+                <a:extLst>
+                  <a:ext uri="{0D108BD9-81ED-4DB2-BD59-A6C34878D82A}">
+                    <a16:rowId xmlns:a16="http://schemas.microsoft.com/office/drawing/2014/main" val="10007"/>
+                  </a:ext>
+                </a:extLst>
               </a:tr>
             </a:tbl>
           </a:graphicData>
@@ -6360,6 +6193,218 @@
     <p:extLst>
       <p:ext uri="{BB962C8B-B14F-4D97-AF65-F5344CB8AC3E}">
         <p14:creationId xmlns:p14="http://schemas.microsoft.com/office/powerpoint/2010/main" val="3231800503"/>
+      </p:ext>
+    </p:extLst>
+  </p:cSld>
+  <p:clrMapOvr>
+    <a:masterClrMapping/>
+  </p:clrMapOvr>
+</p:sld>
+</file>
+
+<file path=ppt/slides/slide16.xml><?xml version="1.0" encoding="utf-8"?>
+<p:sld xmlns:a="http://schemas.openxmlformats.org/drawingml/2006/main" xmlns:r="http://schemas.openxmlformats.org/officeDocument/2006/relationships" xmlns:p="http://schemas.openxmlformats.org/presentationml/2006/main">
+  <p:cSld>
+    <p:spTree>
+      <p:nvGrpSpPr>
+        <p:cNvPr id="1" name=""/>
+        <p:cNvGrpSpPr/>
+        <p:nvPr/>
+      </p:nvGrpSpPr>
+      <p:grpSpPr>
+        <a:xfrm>
+          <a:off x="0" y="0"/>
+          <a:ext cx="0" cy="0"/>
+          <a:chOff x="0" y="0"/>
+          <a:chExt cx="0" cy="0"/>
+        </a:xfrm>
+      </p:grpSpPr>
+      <p:sp>
+        <p:nvSpPr>
+          <p:cNvPr id="2" name="Title 1">
+            <a:extLst>
+              <a:ext uri="{FF2B5EF4-FFF2-40B4-BE49-F238E27FC236}">
+                <a16:creationId xmlns:a16="http://schemas.microsoft.com/office/drawing/2014/main" id="{5B738971-B764-E045-F92B-01E3322A0123}"/>
+              </a:ext>
+            </a:extLst>
+          </p:cNvPr>
+          <p:cNvSpPr>
+            <a:spLocks noGrp="1"/>
+          </p:cNvSpPr>
+          <p:nvPr>
+            <p:ph type="title"/>
+          </p:nvPr>
+        </p:nvSpPr>
+        <p:spPr>
+          <a:xfrm>
+            <a:off x="202676" y="120029"/>
+            <a:ext cx="8738648" cy="747237"/>
+          </a:xfrm>
+        </p:spPr>
+        <p:txBody>
+          <a:bodyPr>
+            <a:noAutofit/>
+          </a:bodyPr>
+          <a:lstStyle/>
+          <a:p>
+            <a:r>
+              <a:rPr lang="en-US" sz="3000" b="1" dirty="0">
+                <a:solidFill>
+                  <a:schemeClr val="accent2">
+                    <a:lumMod val="50000"/>
+                  </a:schemeClr>
+                </a:solidFill>
+                <a:latin typeface="Calisto MT" panose="02040603050505030304" pitchFamily="18" charset="0"/>
+              </a:rPr>
+              <a:t>11. Gap Analysis</a:t>
+            </a:r>
+          </a:p>
+        </p:txBody>
+      </p:sp>
+      <p:sp>
+        <p:nvSpPr>
+          <p:cNvPr id="3" name="Content Placeholder 2">
+            <a:extLst>
+              <a:ext uri="{FF2B5EF4-FFF2-40B4-BE49-F238E27FC236}">
+                <a16:creationId xmlns:a16="http://schemas.microsoft.com/office/drawing/2014/main" id="{E5D502BE-F636-7D1D-85F0-BAFFD3E05E1C}"/>
+              </a:ext>
+            </a:extLst>
+          </p:cNvPr>
+          <p:cNvSpPr>
+            <a:spLocks noGrp="1"/>
+          </p:cNvSpPr>
+          <p:nvPr>
+            <p:ph idx="1"/>
+          </p:nvPr>
+        </p:nvSpPr>
+        <p:spPr>
+          <a:xfrm>
+            <a:off x="358218" y="867265"/>
+            <a:ext cx="8314441" cy="5870705"/>
+          </a:xfrm>
+        </p:spPr>
+        <p:txBody>
+          <a:bodyPr wrap="square" numCol="1">
+            <a:normAutofit/>
+          </a:bodyPr>
+          <a:lstStyle/>
+          <a:p>
+            <a:r>
+              <a:rPr sz="1400" b="1"/>
+              <a:t>Established in the literature</a:t>
+            </a:r>
+          </a:p>
+          <a:p>
+            <a:pPr lvl="1"/>
+            <a:r>
+              <a:rPr sz="1200" b="0"/>
+              <a:t>Foundation models pretrained on Hi-C maps exist (HiCFoundation)</a:t>
+            </a:r>
+          </a:p>
+          <a:p>
+            <a:pPr lvl="1"/>
+            <a:r>
+              <a:rPr sz="1200" b="0"/>
+              <a:t>Multimodal Hi-C and epigenomic pretraining exists (MIX-HIC)</a:t>
+            </a:r>
+          </a:p>
+          <a:p>
+            <a:pPr lvl="1"/>
+            <a:r>
+              <a:rPr sz="1200" b="0"/>
+              <a:t>Hi-C-guided distillation into a DNA encoder exists (Evo2HiC)</a:t>
+            </a:r>
+          </a:p>
+          <a:p>
+            <a:r>
+              <a:rPr sz="1400" b="1"/>
+              <a:t>Still open</a:t>
+            </a:r>
+          </a:p>
+          <a:p>
+            <a:pPr lvl="1"/>
+            <a:r>
+              <a:rPr sz="1200" b="0"/>
+              <a:t>No published model trains a DNA encoder end to end while measured contact graphs control which distal windows exchange information at every layer</a:t>
+            </a:r>
+          </a:p>
+          <a:p>
+            <a:pPr lvl="1"/>
+            <a:r>
+              <a:rPr sz="1200" b="0"/>
+              <a:t>Post-hoc alignment and late fusion have not been separated from in-encoder conditioning under matched parameters, data and compute</a:t>
+            </a:r>
+          </a:p>
+          <a:p>
+            <a:pPr lvl="1"/>
+            <a:r>
+              <a:rPr sz="1200" b="0"/>
+              <a:t>Whether structural knowledge survives removal of Hi-C at inference is asserted more often than it is tested against a shuffled-contact control</a:t>
+            </a:r>
+          </a:p>
+          <a:p>
+            <a:r>
+              <a:rPr sz="1400" b="1"/>
+              <a:t>Gap statement</a:t>
+            </a:r>
+          </a:p>
+          <a:p>
+            <a:pPr lvl="2"/>
+            <a:r>
+              <a:rPr sz="1000" b="0">
+                <a:solidFill>
+                  <a:srgbClr val="595959"/>
+                </a:solidFill>
+              </a:rPr>
+              <a:t>It remains untested whether contact graphs conditioning sequence contextualisation throughout pretraining yield a more transferable DNA representation than the alternatives, measured against distance-matched and shuffled-contact controls.</a:t>
+            </a:r>
+          </a:p>
+        </p:txBody>
+      </p:sp>
+      <p:sp>
+        <p:nvSpPr>
+          <p:cNvPr id="7" name="Slide Number Placeholder 6">
+            <a:extLst>
+              <a:ext uri="{FF2B5EF4-FFF2-40B4-BE49-F238E27FC236}">
+                <a16:creationId xmlns:a16="http://schemas.microsoft.com/office/drawing/2014/main" id="{14F45621-8939-04E9-03B4-11AF180D5862}"/>
+              </a:ext>
+            </a:extLst>
+          </p:cNvPr>
+          <p:cNvSpPr>
+            <a:spLocks noGrp="1"/>
+          </p:cNvSpPr>
+          <p:nvPr>
+            <p:ph type="sldNum" sz="quarter" idx="12"/>
+          </p:nvPr>
+        </p:nvSpPr>
+        <p:spPr/>
+        <p:txBody>
+          <a:bodyPr/>
+          <a:lstStyle/>
+          <a:p>
+            <a:fld id="{D90542D4-23E8-43E0-BA8E-C972DA1A005D}" type="slidenum">
+              <a:rPr lang="en-US" sz="1400" b="1" smtClean="0">
+                <a:solidFill>
+                  <a:schemeClr val="tx1"/>
+                </a:solidFill>
+                <a:latin typeface="Calisto MT" panose="02040603050505030304" pitchFamily="18" charset="0"/>
+              </a:rPr>
+              <a:pPr/>
+              <a:t>16</a:t>
+            </a:fld>
+            <a:endParaRPr lang="en-US" sz="1400" b="1" dirty="0">
+              <a:solidFill>
+                <a:schemeClr val="tx1"/>
+              </a:solidFill>
+              <a:latin typeface="Calisto MT" panose="02040603050505030304" pitchFamily="18" charset="0"/>
+            </a:endParaRPr>
+          </a:p>
+        </p:txBody>
+      </p:sp>
+    </p:spTree>
+    <p:extLst>
+      <p:ext uri="{BB962C8B-B14F-4D97-AF65-F5344CB8AC3E}">
+        <p14:creationId xmlns:p14="http://schemas.microsoft.com/office/powerpoint/2010/main" val="2843785032"/>
       </p:ext>
     </p:extLst>
   </p:cSld>
@@ -6404,18 +6449,18 @@
         </p:nvSpPr>
         <p:spPr>
           <a:xfrm>
-            <a:off x="202676" y="120029"/>
-            <a:ext cx="8738648" cy="747237"/>
+            <a:off x="399166" y="155378"/>
+            <a:ext cx="8006303" cy="549273"/>
           </a:xfrm>
         </p:spPr>
         <p:txBody>
           <a:bodyPr>
-            <a:noAutofit/>
+            <a:normAutofit fontScale="90000"/>
           </a:bodyPr>
           <a:lstStyle/>
           <a:p>
             <a:r>
-              <a:rPr lang="en-US" sz="3000" b="1" dirty="0">
+              <a:rPr lang="en-US" sz="4000" b="1" dirty="0">
                 <a:solidFill>
                   <a:schemeClr val="accent2">
                     <a:lumMod val="50000"/>
@@ -6423,7 +6468,7 @@
                 </a:solidFill>
                 <a:latin typeface="Calisto MT" panose="02040603050505030304" pitchFamily="18" charset="0"/>
               </a:rPr>
-              <a:t>11. Gap Analysis</a:t>
+              <a:t>References</a:t>
             </a:r>
           </a:p>
         </p:txBody>
@@ -6446,97 +6491,121 @@
         </p:nvSpPr>
         <p:spPr>
           <a:xfrm>
-            <a:off x="358218" y="867265"/>
-            <a:ext cx="8314441" cy="5870705"/>
+            <a:off x="509047" y="790756"/>
+            <a:ext cx="8006303" cy="5748157"/>
           </a:xfrm>
         </p:spPr>
         <p:txBody>
-          <a:bodyPr numCol="1" wrap="square">
+          <a:bodyPr wrap="square" numCol="1">
             <a:normAutofit/>
           </a:bodyPr>
           <a:lstStyle/>
           <a:p>
-            <a:pPr/>
-            <a:r>
-              <a:rPr sz="1400" b="1"/>
-              <a:t>Established in the literature</a:t>
-            </a:r>
-          </a:p>
-          <a:p>
-            <a:pPr lvl="1"/>
-            <a:r>
-              <a:rPr sz="1200" b="0"/>
-              <a:t>Foundation models pretrained on Hi-C maps exist (HiCFoundation)</a:t>
-            </a:r>
-          </a:p>
-          <a:p>
-            <a:pPr lvl="1"/>
-            <a:r>
-              <a:rPr sz="1200" b="0"/>
-              <a:t>Multimodal Hi-C and epigenomic pretraining exists (MIX-HIC)</a:t>
-            </a:r>
-          </a:p>
-          <a:p>
-            <a:pPr lvl="1"/>
-            <a:r>
-              <a:rPr sz="1200" b="0"/>
-              <a:t>Hi-C-guided distillation into a DNA encoder exists (Evo2HiC)</a:t>
-            </a:r>
-          </a:p>
-          <a:p>
-            <a:pPr/>
-            <a:r>
-              <a:rPr sz="1400" b="1"/>
-              <a:t>Still open</a:t>
-            </a:r>
-          </a:p>
-          <a:p>
-            <a:pPr lvl="1"/>
-            <a:r>
-              <a:rPr sz="1200" b="0"/>
-              <a:t>No published model trains a DNA encoder end to end while measured contact graphs control which distal windows exchange information at every layer</a:t>
-            </a:r>
-          </a:p>
-          <a:p>
-            <a:pPr lvl="1"/>
-            <a:r>
-              <a:rPr sz="1200" b="0"/>
-              <a:t>Post-hoc alignment and late fusion have not been separated from in-encoder conditioning under matched parameters, data and compute</a:t>
-            </a:r>
-          </a:p>
-          <a:p>
-            <a:pPr lvl="1"/>
-            <a:r>
-              <a:rPr sz="1200" b="0"/>
-              <a:t>Whether structural knowledge survives removal of Hi-C at inference is asserted more often than it is tested against a shuffled-contact control</a:t>
-            </a:r>
-          </a:p>
-          <a:p>
-            <a:pPr/>
-            <a:r>
-              <a:rPr sz="1400" b="1"/>
-              <a:t>Gap statement</a:t>
-            </a:r>
-          </a:p>
-          <a:p>
-            <a:pPr lvl="2"/>
-            <a:r>
-              <a:rPr sz="1000" b="0">
-                <a:solidFill>
-                  <a:srgbClr val="595959"/>
-                </a:solidFill>
-              </a:rPr>
-              <a:t>It remains untested whether contact graphs conditioning sequence contextualisation throughout pretraining yield a more transferable DNA representation than the alternatives, measured against distance-matched and shuffled-contact controls.</a:t>
-            </a:r>
-          </a:p>
-        </p:txBody>
-      </p:sp>
-      <p:sp>
-        <p:nvSpPr>
-          <p:cNvPr id="7" name="Slide Number Placeholder 6">
+            <a:r>
+              <a:rPr sz="900" b="0" dirty="0"/>
+              <a:t>[1] </a:t>
+            </a:r>
+            <a:r>
+              <a:rPr sz="900" b="0" dirty="0" err="1"/>
+              <a:t>Fudenberg</a:t>
+            </a:r>
+            <a:r>
+              <a:rPr sz="900" b="0" dirty="0"/>
+              <a:t>, G., Kelley, D. R., &amp; Pollard, K. S. (2020). Predicting 3D genome folding from DNA sequence with Akita. Nature Methods, 17(11), 1111-1117.</a:t>
+            </a:r>
+          </a:p>
+          <a:p>
+            <a:r>
+              <a:rPr sz="900" b="0" dirty="0"/>
+              <a:t>[2] Tan, J., et al. (2023). Cell-type-specific prediction of 3D chromatin organization enables high-throughput in silico genetic screening. Nature Biotechnology, 41(8), 1140-1150.</a:t>
+            </a:r>
+          </a:p>
+          <a:p>
+            <a:r>
+              <a:rPr sz="900" b="0" dirty="0"/>
+              <a:t>[3] Zhang, Z., et al. (2023). A generalizable framework to comprehensively predict epigenome, chromatin organization, and transcriptome. Nucleic Acids Research, 51(12), 5931-5947.</a:t>
+            </a:r>
+          </a:p>
+          <a:p>
+            <a:r>
+              <a:rPr sz="900" b="0" dirty="0"/>
+              <a:t>[4] Schiff, Y., et al. (2024). Caduceus: Bi-directional equivariant long-range DNA sequence modeling. arXiv:2403.03234.</a:t>
+            </a:r>
+          </a:p>
+          <a:p>
+            <a:r>
+              <a:rPr sz="900" b="0" dirty="0"/>
+              <a:t>[5] A generalizable Hi-C foundation model for chromatin architecture, single-cell and multi-omics analysis across species (</a:t>
+            </a:r>
+            <a:r>
+              <a:rPr sz="900" b="0" dirty="0" err="1"/>
+              <a:t>HiCFoundation</a:t>
+            </a:r>
+            <a:r>
+              <a:rPr sz="900" b="0" dirty="0"/>
+              <a:t>). Nature Methods (2026).</a:t>
+            </a:r>
+          </a:p>
+          <a:p>
+            <a:r>
+              <a:rPr sz="900" b="0" dirty="0"/>
+              <a:t>[6] MIX-HIC: Multimodal 3D Genome Pre-training. arXiv:2504.09060 (2025).</a:t>
+            </a:r>
+          </a:p>
+          <a:p>
+            <a:r>
+              <a:rPr sz="900" b="0" dirty="0"/>
+              <a:t>[7] Evo2HiC: a multimodal foundation model for integrative analysis of genome sequence and architecture. bioRxiv 2025.11.18.689171 (2025).</a:t>
+            </a:r>
+          </a:p>
+          <a:p>
+            <a:r>
+              <a:rPr sz="900" b="0" dirty="0"/>
+              <a:t>[8] Gu, A., &amp; Dao, T. (2023). Mamba: Linear-time sequence modeling with selective state spaces. arXiv:2312.00752.</a:t>
+            </a:r>
+          </a:p>
+          <a:p>
+            <a:r>
+              <a:rPr sz="900" b="0" dirty="0"/>
+              <a:t>[9] Vaswani, A., et al. (2017). Attention is all you need. </a:t>
+            </a:r>
+            <a:r>
+              <a:rPr sz="900" b="0" dirty="0" err="1"/>
+              <a:t>NeurIPS</a:t>
+            </a:r>
+            <a:r>
+              <a:rPr sz="900" b="0" dirty="0"/>
+              <a:t> 2017.</a:t>
+            </a:r>
+          </a:p>
+          <a:p>
+            <a:r>
+              <a:rPr sz="900" b="0" dirty="0"/>
+              <a:t>[10] Rao, S. S. P., et al. (2014). A 3D map of the human genome at kilobase resolution reveals principles of chromatin looping. Cell, 159(7), 1665-1680.</a:t>
+            </a:r>
+          </a:p>
+          <a:p>
+            <a:r>
+              <a:rPr sz="900" b="0" dirty="0"/>
+              <a:t>[11] </a:t>
+            </a:r>
+            <a:r>
+              <a:rPr sz="900" b="0" dirty="0" err="1"/>
+              <a:t>Abdennur</a:t>
+            </a:r>
+            <a:r>
+              <a:rPr sz="900" b="0" dirty="0"/>
+              <a:t>, N., &amp; Mirny, L. A. (2020). Cooler: scalable storage for Hi-C data and other genomically labeled arrays. Bioinformatics, 36(1), 311-316.</a:t>
+            </a:r>
+          </a:p>
+        </p:txBody>
+      </p:sp>
+      <p:sp>
+        <p:nvSpPr>
+          <p:cNvPr id="6" name="Slide Number Placeholder 5">
             <a:extLst>
               <a:ext uri="{FF2B5EF4-FFF2-40B4-BE49-F238E27FC236}">
-                <a16:creationId xmlns:a16="http://schemas.microsoft.com/office/drawing/2014/main" id="{14F45621-8939-04E9-03B4-11AF180D5862}"/>
+                <a16:creationId xmlns:a16="http://schemas.microsoft.com/office/drawing/2014/main" id="{1F9ED706-BAAD-007D-D4CC-247F422DF465}"/>
               </a:ext>
             </a:extLst>
           </p:cNvPr>
@@ -6574,7 +6643,160 @@
     </p:spTree>
     <p:extLst>
       <p:ext uri="{BB962C8B-B14F-4D97-AF65-F5344CB8AC3E}">
-        <p14:creationId xmlns:p14="http://schemas.microsoft.com/office/powerpoint/2010/main" val="2843785032"/>
+        <p14:creationId xmlns:p14="http://schemas.microsoft.com/office/powerpoint/2010/main" val="4037050892"/>
+      </p:ext>
+    </p:extLst>
+  </p:cSld>
+  <p:clrMapOvr>
+    <a:masterClrMapping/>
+  </p:clrMapOvr>
+</p:sld>
+</file>
+
+<file path=ppt/slides/slide2.xml><?xml version="1.0" encoding="utf-8"?>
+<p:sld xmlns:a="http://schemas.openxmlformats.org/drawingml/2006/main" xmlns:r="http://schemas.openxmlformats.org/officeDocument/2006/relationships" xmlns:p="http://schemas.openxmlformats.org/presentationml/2006/main">
+  <p:cSld>
+    <p:spTree>
+      <p:nvGrpSpPr>
+        <p:cNvPr id="1" name=""/>
+        <p:cNvGrpSpPr/>
+        <p:nvPr/>
+      </p:nvGrpSpPr>
+      <p:grpSpPr>
+        <a:xfrm>
+          <a:off x="0" y="0"/>
+          <a:ext cx="0" cy="0"/>
+          <a:chOff x="0" y="0"/>
+          <a:chExt cx="0" cy="0"/>
+        </a:xfrm>
+      </p:grpSpPr>
+      <p:sp>
+        <p:nvSpPr>
+          <p:cNvPr id="2" name="Title 1">
+            <a:extLst>
+              <a:ext uri="{FF2B5EF4-FFF2-40B4-BE49-F238E27FC236}">
+                <a16:creationId xmlns:a16="http://schemas.microsoft.com/office/drawing/2014/main" id="{5B738971-B764-E045-F92B-01E3322A0123}"/>
+              </a:ext>
+            </a:extLst>
+          </p:cNvPr>
+          <p:cNvSpPr>
+            <a:spLocks noGrp="1"/>
+          </p:cNvSpPr>
+          <p:nvPr>
+            <p:ph type="title"/>
+          </p:nvPr>
+        </p:nvSpPr>
+        <p:spPr>
+          <a:xfrm>
+            <a:off x="628650" y="214298"/>
+            <a:ext cx="7886700" cy="709530"/>
+          </a:xfrm>
+        </p:spPr>
+        <p:txBody>
+          <a:bodyPr/>
+          <a:lstStyle/>
+          <a:p>
+            <a:r>
+              <a:rPr lang="en-US" sz="3600" b="1">
+                <a:solidFill>
+                  <a:schemeClr val="accent2">
+                    <a:lumMod val="50000"/>
+                  </a:schemeClr>
+                </a:solidFill>
+                <a:latin typeface="Calisto MT" panose="02040603050505030304" pitchFamily="18" charset="0"/>
+              </a:rPr>
+              <a:t>Abstract</a:t>
+            </a:r>
+            <a:endParaRPr lang="en-US" b="1" dirty="0">
+              <a:solidFill>
+                <a:schemeClr val="accent2">
+                  <a:lumMod val="50000"/>
+                </a:schemeClr>
+              </a:solidFill>
+              <a:latin typeface="Calisto MT" panose="02040603050505030304" pitchFamily="18" charset="0"/>
+            </a:endParaRPr>
+          </a:p>
+        </p:txBody>
+      </p:sp>
+      <p:sp>
+        <p:nvSpPr>
+          <p:cNvPr id="3" name="Content Placeholder 2">
+            <a:extLst>
+              <a:ext uri="{FF2B5EF4-FFF2-40B4-BE49-F238E27FC236}">
+                <a16:creationId xmlns:a16="http://schemas.microsoft.com/office/drawing/2014/main" id="{E5D502BE-F636-7D1D-85F0-BAFFD3E05E1C}"/>
+              </a:ext>
+            </a:extLst>
+          </p:cNvPr>
+          <p:cNvSpPr>
+            <a:spLocks noGrp="1"/>
+          </p:cNvSpPr>
+          <p:nvPr>
+            <p:ph idx="1"/>
+          </p:nvPr>
+        </p:nvSpPr>
+        <p:spPr>
+          <a:xfrm>
+            <a:off x="628649" y="1046376"/>
+            <a:ext cx="8062863" cy="5253135"/>
+          </a:xfrm>
+        </p:spPr>
+        <p:txBody>
+          <a:bodyPr wrap="square">
+            <a:normAutofit/>
+          </a:bodyPr>
+          <a:lstStyle/>
+          <a:p>
+            <a:r>
+              <a:rPr sz="1400" b="0"/>
+              <a:t>Three-dimensional chromatin organisation lets distal regulatory elements control gene expression, yet most genomic sequence models treat the genome as a one-dimensional string. This project develops ChromGraphFM, a compact 3D chromatin-conditioned genomic representation model trained from scratch on DNA sequence and Hi-C contact maps. Genomic regions become nodes in a sparse contact graph, and measured Hi-C contact strengths bias attention among distant DNA windows throughout self-supervised pretraining, so structure shapes the sequence representation instead of being appended after it. Pretraining combines masked DNA modelling, distance-matched contact-aware contrastive learning, and chromatin contact prediction. The model is evaluated against sequence-only, shuffled-contact, distance-only, random-graph and late-fusion controls trained at matched parameters, data and compute, using chromosome-level and cell-type held-out splits for contact-map prediction, chromatin loop detection, enhancer-promoter linking and Hi-C-free transfer. The central question is whether experimentally measured 3D structure can be internalised into a reusable DNA representation rather than supplied as an extra input at prediction time.</a:t>
+            </a:r>
+          </a:p>
+        </p:txBody>
+      </p:sp>
+      <p:sp>
+        <p:nvSpPr>
+          <p:cNvPr id="5" name="Slide Number Placeholder 4">
+            <a:extLst>
+              <a:ext uri="{FF2B5EF4-FFF2-40B4-BE49-F238E27FC236}">
+                <a16:creationId xmlns:a16="http://schemas.microsoft.com/office/drawing/2014/main" id="{02E3089C-7D4B-76D0-EDD6-D1FEEE855B77}"/>
+              </a:ext>
+            </a:extLst>
+          </p:cNvPr>
+          <p:cNvSpPr>
+            <a:spLocks noGrp="1"/>
+          </p:cNvSpPr>
+          <p:nvPr>
+            <p:ph type="sldNum" sz="quarter" idx="12"/>
+          </p:nvPr>
+        </p:nvSpPr>
+        <p:spPr/>
+        <p:txBody>
+          <a:bodyPr/>
+          <a:lstStyle/>
+          <a:p>
+            <a:fld id="{D90542D4-23E8-43E0-BA8E-C972DA1A005D}" type="slidenum">
+              <a:rPr lang="en-US" sz="1400" b="1" smtClean="0">
+                <a:solidFill>
+                  <a:schemeClr val="tx1"/>
+                </a:solidFill>
+                <a:latin typeface="Calisto MT" panose="02040603050505030304" pitchFamily="18" charset="0"/>
+              </a:rPr>
+              <a:pPr/>
+              <a:t>2</a:t>
+            </a:fld>
+            <a:endParaRPr lang="en-US" sz="1400" b="1" dirty="0">
+              <a:solidFill>
+                <a:schemeClr val="tx1"/>
+              </a:solidFill>
+              <a:latin typeface="Calisto MT" panose="02040603050505030304" pitchFamily="18" charset="0"/>
+            </a:endParaRPr>
+          </a:p>
+        </p:txBody>
+      </p:sp>
+    </p:spTree>
+    <p:extLst>
+      <p:ext uri="{BB962C8B-B14F-4D97-AF65-F5344CB8AC3E}">
+        <p14:creationId xmlns:p14="http://schemas.microsoft.com/office/powerpoint/2010/main" val="3775680061"/>
       </p:ext>
     </p:extLst>
   </p:cSld>
@@ -6619,16 +6841,18 @@
         </p:nvSpPr>
         <p:spPr>
           <a:xfrm>
-            <a:off x="628650" y="214298"/>
-            <a:ext cx="7886700" cy="709530"/>
+            <a:off x="405352" y="120030"/>
+            <a:ext cx="7886700" cy="549273"/>
           </a:xfrm>
         </p:spPr>
         <p:txBody>
-          <a:bodyPr/>
-          <a:lstStyle/>
-          <a:p>
-            <a:r>
-              <a:rPr lang="en-US" sz="3600" b="1">
+          <a:bodyPr>
+            <a:normAutofit fontScale="90000"/>
+          </a:bodyPr>
+          <a:lstStyle/>
+          <a:p>
+            <a:r>
+              <a:rPr lang="en-US" sz="4000" b="1">
                 <a:solidFill>
                   <a:schemeClr val="accent2">
                     <a:lumMod val="50000"/>
@@ -6636,9 +6860,9 @@
                 </a:solidFill>
                 <a:latin typeface="Calisto MT" panose="02040603050505030304" pitchFamily="18" charset="0"/>
               </a:rPr>
-              <a:t>Abstract</a:t>
-            </a:r>
-            <a:endParaRPr lang="en-US" b="1" dirty="0">
+              <a:t>Presentation Outline</a:t>
+            </a:r>
+            <a:endParaRPr lang="en-US" sz="4000" b="1" dirty="0">
               <a:solidFill>
                 <a:schemeClr val="accent2">
                   <a:lumMod val="50000"/>
@@ -6667,30 +6891,143 @@
         </p:nvSpPr>
         <p:spPr>
           <a:xfrm>
-            <a:off x="628649" y="1046376"/>
-            <a:ext cx="8062863" cy="5253135"/>
+            <a:off x="405352" y="687062"/>
+            <a:ext cx="8634953" cy="5851851"/>
           </a:xfrm>
         </p:spPr>
         <p:txBody>
-          <a:bodyPr wrap="square">
-            <a:normAutofit/>
+          <a:bodyPr wrap="square" numCol="2">
+            <a:normAutofit fontScale="25000" lnSpcReduction="20000"/>
           </a:bodyPr>
           <a:lstStyle/>
           <a:p>
-            <a:pPr/>
-            <a:r>
-              <a:rPr sz="1400" b="0"/>
-              <a:t>Three-dimensional chromatin organisation lets distal regulatory elements control gene expression, yet most genomic sequence models treat the genome as a one-dimensional string. This project develops ChromGraphFM, a compact 3D chromatin-conditioned genomic representation model trained from scratch on DNA sequence and Hi-C contact maps. Genomic regions become nodes in a sparse contact graph, and measured Hi-C contact strengths bias attention among distant DNA windows throughout self-supervised pretraining, so structure shapes the sequence representation instead of being appended after it. Pretraining combines masked DNA modelling, distance-matched contact-aware contrastive learning, and chromatin contact prediction. The model is evaluated against sequence-only, shuffled-contact, distance-only, random-graph and late-fusion controls trained at matched parameters, data and compute, using chromosome-level and cell-type held-out splits for contact-map prediction, chromatin loop detection, enhancer-promoter linking and Hi-C-free transfer. The central question is whether experimentally measured 3D structure can be internalised into a reusable DNA representation rather than supplied as an extra input at prediction time.</a:t>
-            </a:r>
-          </a:p>
-        </p:txBody>
-      </p:sp>
-      <p:sp>
-        <p:nvSpPr>
-          <p:cNvPr id="5" name="Slide Number Placeholder 4">
+            <a:r>
+              <a:rPr sz="1200" b="0"/>
+              <a:t>1. Research Domain</a:t>
+            </a:r>
+          </a:p>
+          <a:p>
+            <a:r>
+              <a:rPr sz="1200" b="0"/>
+              <a:t>2. SDG Categories</a:t>
+            </a:r>
+          </a:p>
+          <a:p>
+            <a:r>
+              <a:rPr sz="1200" b="0"/>
+              <a:t>3. Aim and Motivation</a:t>
+            </a:r>
+          </a:p>
+          <a:p>
+            <a:r>
+              <a:rPr sz="1200" b="0"/>
+              <a:t>4. Research Questions</a:t>
+            </a:r>
+          </a:p>
+          <a:p>
+            <a:r>
+              <a:rPr sz="1200" b="0"/>
+              <a:t>5. Title Justification</a:t>
+            </a:r>
+          </a:p>
+          <a:p>
+            <a:r>
+              <a:rPr sz="1200" b="0"/>
+              <a:t>6. Objectives</a:t>
+            </a:r>
+          </a:p>
+          <a:p>
+            <a:r>
+              <a:rPr sz="1200" b="0"/>
+              <a:t>7. Scope</a:t>
+            </a:r>
+          </a:p>
+          <a:p>
+            <a:r>
+              <a:rPr sz="1200" b="0"/>
+              <a:t>8. Timeline Chart</a:t>
+            </a:r>
+          </a:p>
+          <a:p>
+            <a:r>
+              <a:rPr sz="1200" b="0"/>
+              <a:t>9. Introduction</a:t>
+            </a:r>
+          </a:p>
+          <a:p>
+            <a:r>
+              <a:rPr sz="1200" b="0"/>
+              <a:t>10. Study on Existing Technologies</a:t>
+            </a:r>
+          </a:p>
+          <a:p>
+            <a:r>
+              <a:rPr sz="1200" b="0"/>
+              <a:t>11. Gap Analysis</a:t>
+            </a:r>
+          </a:p>
+          <a:p>
+            <a:r>
+              <a:rPr sz="1200" b="0"/>
+              <a:t>12. SDLC Model</a:t>
+            </a:r>
+          </a:p>
+          <a:p>
+            <a:r>
+              <a:rPr sz="1200" b="0"/>
+              <a:t>13. UML Diagrams</a:t>
+            </a:r>
+          </a:p>
+          <a:p>
+            <a:r>
+              <a:rPr sz="1200" b="0"/>
+              <a:t>14. Functional and Non-Functional Requirements</a:t>
+            </a:r>
+          </a:p>
+          <a:p>
+            <a:r>
+              <a:rPr sz="1200" b="0"/>
+              <a:t>15. Data Collection</a:t>
+            </a:r>
+          </a:p>
+          <a:p>
+            <a:r>
+              <a:rPr sz="1200" b="0"/>
+              <a:t>16. Data Preparation</a:t>
+            </a:r>
+          </a:p>
+          <a:p>
+            <a:r>
+              <a:rPr sz="1200" b="0"/>
+              <a:t>17. Proposed System Architecture</a:t>
+            </a:r>
+          </a:p>
+          <a:p>
+            <a:r>
+              <a:rPr sz="1200" b="0"/>
+              <a:t>18. Experimental Setup and Results</a:t>
+            </a:r>
+          </a:p>
+          <a:p>
+            <a:r>
+              <a:rPr sz="1200" b="0"/>
+              <a:t>19. Project Outcomes</a:t>
+            </a:r>
+          </a:p>
+          <a:p>
+            <a:r>
+              <a:rPr sz="1200" b="0"/>
+              <a:t>20. Conclusion and Future Work</a:t>
+            </a:r>
+          </a:p>
+        </p:txBody>
+      </p:sp>
+      <p:sp>
+        <p:nvSpPr>
+          <p:cNvPr id="6" name="Slide Number Placeholder 5">
             <a:extLst>
               <a:ext uri="{FF2B5EF4-FFF2-40B4-BE49-F238E27FC236}">
-                <a16:creationId xmlns:a16="http://schemas.microsoft.com/office/drawing/2014/main" id="{02E3089C-7D4B-76D0-EDD6-D1FEEE855B77}"/>
+                <a16:creationId xmlns:a16="http://schemas.microsoft.com/office/drawing/2014/main" id="{971C3DE6-22F4-4655-E43D-E5183840B449}"/>
               </a:ext>
             </a:extLst>
           </p:cNvPr>
@@ -6728,225 +7065,7 @@
     </p:spTree>
     <p:extLst>
       <p:ext uri="{BB962C8B-B14F-4D97-AF65-F5344CB8AC3E}">
-        <p14:creationId xmlns:p14="http://schemas.microsoft.com/office/powerpoint/2010/main" val="3775680061"/>
-      </p:ext>
-    </p:extLst>
-  </p:cSld>
-  <p:clrMapOvr>
-    <a:masterClrMapping/>
-  </p:clrMapOvr>
-</p:sld>
-</file>
-
-<file path=ppt/slides/slide38.xml><?xml version="1.0" encoding="utf-8"?>
-<p:sld xmlns:a="http://schemas.openxmlformats.org/drawingml/2006/main" xmlns:r="http://schemas.openxmlformats.org/officeDocument/2006/relationships" xmlns:p="http://schemas.openxmlformats.org/presentationml/2006/main">
-  <p:cSld>
-    <p:spTree>
-      <p:nvGrpSpPr>
-        <p:cNvPr id="1" name=""/>
-        <p:cNvGrpSpPr/>
-        <p:nvPr/>
-      </p:nvGrpSpPr>
-      <p:grpSpPr>
-        <a:xfrm>
-          <a:off x="0" y="0"/>
-          <a:ext cx="0" cy="0"/>
-          <a:chOff x="0" y="0"/>
-          <a:chExt cx="0" cy="0"/>
-        </a:xfrm>
-      </p:grpSpPr>
-      <p:sp>
-        <p:nvSpPr>
-          <p:cNvPr id="2" name="Title 1">
-            <a:extLst>
-              <a:ext uri="{FF2B5EF4-FFF2-40B4-BE49-F238E27FC236}">
-                <a16:creationId xmlns:a16="http://schemas.microsoft.com/office/drawing/2014/main" id="{5B738971-B764-E045-F92B-01E3322A0123}"/>
-              </a:ext>
-            </a:extLst>
-          </p:cNvPr>
-          <p:cNvSpPr>
-            <a:spLocks noGrp="1"/>
-          </p:cNvSpPr>
-          <p:nvPr>
-            <p:ph type="title"/>
-          </p:nvPr>
-        </p:nvSpPr>
-        <p:spPr>
-          <a:xfrm>
-            <a:off x="399166" y="155378"/>
-            <a:ext cx="8006303" cy="549273"/>
-          </a:xfrm>
-        </p:spPr>
-        <p:txBody>
-          <a:bodyPr>
-            <a:normAutofit fontScale="90000"/>
-          </a:bodyPr>
-          <a:lstStyle/>
-          <a:p>
-            <a:r>
-              <a:rPr lang="en-US" sz="4000" b="1" dirty="0">
-                <a:solidFill>
-                  <a:schemeClr val="accent2">
-                    <a:lumMod val="50000"/>
-                  </a:schemeClr>
-                </a:solidFill>
-                <a:latin typeface="Calisto MT" panose="02040603050505030304" pitchFamily="18" charset="0"/>
-              </a:rPr>
-              <a:t>References</a:t>
-            </a:r>
-          </a:p>
-        </p:txBody>
-      </p:sp>
-      <p:sp>
-        <p:nvSpPr>
-          <p:cNvPr id="3" name="Content Placeholder 2">
-            <a:extLst>
-              <a:ext uri="{FF2B5EF4-FFF2-40B4-BE49-F238E27FC236}">
-                <a16:creationId xmlns:a16="http://schemas.microsoft.com/office/drawing/2014/main" id="{E5D502BE-F636-7D1D-85F0-BAFFD3E05E1C}"/>
-              </a:ext>
-            </a:extLst>
-          </p:cNvPr>
-          <p:cNvSpPr>
-            <a:spLocks noGrp="1"/>
-          </p:cNvSpPr>
-          <p:nvPr>
-            <p:ph idx="1"/>
-          </p:nvPr>
-        </p:nvSpPr>
-        <p:spPr>
-          <a:xfrm>
-            <a:off x="509047" y="790756"/>
-            <a:ext cx="8006303" cy="5748157"/>
-          </a:xfrm>
-        </p:spPr>
-        <p:txBody>
-          <a:bodyPr numCol="1" wrap="square">
-            <a:normAutofit/>
-          </a:bodyPr>
-          <a:lstStyle/>
-          <a:p>
-            <a:pPr/>
-            <a:r>
-              <a:rPr sz="900" b="0"/>
-              <a:t>[1] Fudenberg, G., Kelley, D. R., &amp; Pollard, K. S. (2020). Predicting 3D genome folding from DNA sequence with Akita. Nature Methods, 17(11), 1111-1117.</a:t>
-            </a:r>
-          </a:p>
-          <a:p>
-            <a:pPr/>
-            <a:r>
-              <a:rPr sz="900" b="0"/>
-              <a:t>[2] Tan, J., et al. (2023). Cell-type-specific prediction of 3D chromatin organization enables high-throughput in silico genetic screening. Nature Biotechnology, 41(8), 1140-1150.</a:t>
-            </a:r>
-          </a:p>
-          <a:p>
-            <a:pPr/>
-            <a:r>
-              <a:rPr sz="900" b="0"/>
-              <a:t>[3] Zhang, Z., et al. (2023). A generalizable framework to comprehensively predict epigenome, chromatin organization, and transcriptome. Nucleic Acids Research, 51(12), 5931-5947.</a:t>
-            </a:r>
-          </a:p>
-          <a:p>
-            <a:pPr/>
-            <a:r>
-              <a:rPr sz="900" b="0"/>
-              <a:t>[4] Schiff, Y., et al. (2024). Caduceus: Bi-directional equivariant long-range DNA sequence modeling. arXiv:2403.03234.</a:t>
-            </a:r>
-          </a:p>
-          <a:p>
-            <a:pPr/>
-            <a:r>
-              <a:rPr sz="900" b="0"/>
-              <a:t>[5] A generalizable Hi-C foundation model for chromatin architecture, single-cell and multi-omics analysis across species (HiCFoundation). Nature Methods (2026).</a:t>
-            </a:r>
-          </a:p>
-          <a:p>
-            <a:pPr/>
-            <a:r>
-              <a:rPr sz="900" b="0"/>
-              <a:t>[6] MIX-HIC: Multimodal 3D Genome Pre-training. arXiv:2504.09060 (2025).</a:t>
-            </a:r>
-          </a:p>
-          <a:p>
-            <a:pPr/>
-            <a:r>
-              <a:rPr sz="900" b="0"/>
-              <a:t>[7] Evo2HiC: a multimodal foundation model for integrative analysis of genome sequence and architecture. bioRxiv 2025.11.18.689171 (2025).</a:t>
-            </a:r>
-          </a:p>
-          <a:p>
-            <a:pPr/>
-            <a:r>
-              <a:rPr sz="900" b="0"/>
-              <a:t>[8] Gu, A., &amp; Dao, T. (2023). Mamba: Linear-time sequence modeling with selective state spaces. arXiv:2312.00752.</a:t>
-            </a:r>
-          </a:p>
-          <a:p>
-            <a:pPr/>
-            <a:r>
-              <a:rPr sz="900" b="0"/>
-              <a:t>[9] Vaswani, A., et al. (2017). Attention is all you need. NeurIPS 2017.</a:t>
-            </a:r>
-          </a:p>
-          <a:p>
-            <a:pPr/>
-            <a:r>
-              <a:rPr sz="900" b="0"/>
-              <a:t>[10] Rao, S. S. P., et al. (2014). A 3D map of the human genome at kilobase resolution reveals principles of chromatin looping. Cell, 159(7), 1665-1680.</a:t>
-            </a:r>
-          </a:p>
-          <a:p>
-            <a:pPr/>
-            <a:r>
-              <a:rPr sz="900" b="0"/>
-              <a:t>[11] Abdennur, N., &amp; Mirny, L. A. (2020). Cooler: scalable storage for Hi-C data and other genomically labeled arrays. Bioinformatics, 36(1), 311-316.</a:t>
-            </a:r>
-          </a:p>
-        </p:txBody>
-      </p:sp>
-      <p:sp>
-        <p:nvSpPr>
-          <p:cNvPr id="6" name="Slide Number Placeholder 5">
-            <a:extLst>
-              <a:ext uri="{FF2B5EF4-FFF2-40B4-BE49-F238E27FC236}">
-                <a16:creationId xmlns:a16="http://schemas.microsoft.com/office/drawing/2014/main" id="{1F9ED706-BAAD-007D-D4CC-247F422DF465}"/>
-              </a:ext>
-            </a:extLst>
-          </p:cNvPr>
-          <p:cNvSpPr>
-            <a:spLocks noGrp="1"/>
-          </p:cNvSpPr>
-          <p:nvPr>
-            <p:ph type="sldNum" sz="quarter" idx="12"/>
-          </p:nvPr>
-        </p:nvSpPr>
-        <p:spPr/>
-        <p:txBody>
-          <a:bodyPr/>
-          <a:lstStyle/>
-          <a:p>
-            <a:fld id="{D90542D4-23E8-43E0-BA8E-C972DA1A005D}" type="slidenum">
-              <a:rPr lang="en-US" sz="1400" b="1" smtClean="0">
-                <a:solidFill>
-                  <a:schemeClr val="tx1"/>
-                </a:solidFill>
-                <a:latin typeface="Calisto MT" panose="02040603050505030304" pitchFamily="18" charset="0"/>
-              </a:rPr>
-              <a:pPr/>
-              <a:t>38</a:t>
-            </a:fld>
-            <a:endParaRPr lang="en-US" sz="1400" b="1" dirty="0">
-              <a:solidFill>
-                <a:schemeClr val="tx1"/>
-              </a:solidFill>
-              <a:latin typeface="Calisto MT" panose="02040603050505030304" pitchFamily="18" charset="0"/>
-            </a:endParaRPr>
-          </a:p>
-        </p:txBody>
-      </p:sp>
-    </p:spTree>
-    <p:extLst>
-      <p:ext uri="{BB962C8B-B14F-4D97-AF65-F5344CB8AC3E}">
-        <p14:creationId xmlns:p14="http://schemas.microsoft.com/office/powerpoint/2010/main" val="4037050892"/>
+        <p14:creationId xmlns:p14="http://schemas.microsoft.com/office/powerpoint/2010/main" val="1397598054"/>
       </p:ext>
     </p:extLst>
   </p:cSld>
@@ -6957,295 +7076,6 @@
 </file>
 
 <file path=ppt/slides/slide4.xml><?xml version="1.0" encoding="utf-8"?>
-<p:sld xmlns:a="http://schemas.openxmlformats.org/drawingml/2006/main" xmlns:r="http://schemas.openxmlformats.org/officeDocument/2006/relationships" xmlns:p="http://schemas.openxmlformats.org/presentationml/2006/main">
-  <p:cSld>
-    <p:spTree>
-      <p:nvGrpSpPr>
-        <p:cNvPr id="1" name=""/>
-        <p:cNvGrpSpPr/>
-        <p:nvPr/>
-      </p:nvGrpSpPr>
-      <p:grpSpPr>
-        <a:xfrm>
-          <a:off x="0" y="0"/>
-          <a:ext cx="0" cy="0"/>
-          <a:chOff x="0" y="0"/>
-          <a:chExt cx="0" cy="0"/>
-        </a:xfrm>
-      </p:grpSpPr>
-      <p:sp>
-        <p:nvSpPr>
-          <p:cNvPr id="2" name="Title 1">
-            <a:extLst>
-              <a:ext uri="{FF2B5EF4-FFF2-40B4-BE49-F238E27FC236}">
-                <a16:creationId xmlns:a16="http://schemas.microsoft.com/office/drawing/2014/main" id="{5B738971-B764-E045-F92B-01E3322A0123}"/>
-              </a:ext>
-            </a:extLst>
-          </p:cNvPr>
-          <p:cNvSpPr>
-            <a:spLocks noGrp="1"/>
-          </p:cNvSpPr>
-          <p:nvPr>
-            <p:ph type="title"/>
-          </p:nvPr>
-        </p:nvSpPr>
-        <p:spPr>
-          <a:xfrm>
-            <a:off x="405352" y="120030"/>
-            <a:ext cx="7886700" cy="549273"/>
-          </a:xfrm>
-        </p:spPr>
-        <p:txBody>
-          <a:bodyPr>
-            <a:normAutofit fontScale="90000"/>
-          </a:bodyPr>
-          <a:lstStyle/>
-          <a:p>
-            <a:r>
-              <a:rPr lang="en-US" sz="4000" b="1">
-                <a:solidFill>
-                  <a:schemeClr val="accent2">
-                    <a:lumMod val="50000"/>
-                  </a:schemeClr>
-                </a:solidFill>
-                <a:latin typeface="Calisto MT" panose="02040603050505030304" pitchFamily="18" charset="0"/>
-              </a:rPr>
-              <a:t>Presentation Outline</a:t>
-            </a:r>
-            <a:endParaRPr lang="en-US" sz="4000" b="1" dirty="0">
-              <a:solidFill>
-                <a:schemeClr val="accent2">
-                  <a:lumMod val="50000"/>
-                </a:schemeClr>
-              </a:solidFill>
-              <a:latin typeface="Calisto MT" panose="02040603050505030304" pitchFamily="18" charset="0"/>
-            </a:endParaRPr>
-          </a:p>
-        </p:txBody>
-      </p:sp>
-      <p:sp>
-        <p:nvSpPr>
-          <p:cNvPr id="3" name="Content Placeholder 2">
-            <a:extLst>
-              <a:ext uri="{FF2B5EF4-FFF2-40B4-BE49-F238E27FC236}">
-                <a16:creationId xmlns:a16="http://schemas.microsoft.com/office/drawing/2014/main" id="{E5D502BE-F636-7D1D-85F0-BAFFD3E05E1C}"/>
-              </a:ext>
-            </a:extLst>
-          </p:cNvPr>
-          <p:cNvSpPr>
-            <a:spLocks noGrp="1"/>
-          </p:cNvSpPr>
-          <p:nvPr>
-            <p:ph idx="1"/>
-          </p:nvPr>
-        </p:nvSpPr>
-        <p:spPr>
-          <a:xfrm>
-            <a:off x="405352" y="687062"/>
-            <a:ext cx="8634953" cy="5851851"/>
-          </a:xfrm>
-        </p:spPr>
-        <p:txBody>
-          <a:bodyPr numCol="2" wrap="square">
-            <a:normAutofit fontScale="25000" lnSpcReduction="20000"/>
-          </a:bodyPr>
-          <a:lstStyle/>
-          <a:p>
-            <a:pPr/>
-            <a:r>
-              <a:rPr sz="1200" b="0"/>
-              <a:t>1. Research Domain</a:t>
-            </a:r>
-          </a:p>
-          <a:p>
-            <a:pPr/>
-            <a:r>
-              <a:rPr sz="1200" b="0"/>
-              <a:t>2. SDG Categories</a:t>
-            </a:r>
-          </a:p>
-          <a:p>
-            <a:pPr/>
-            <a:r>
-              <a:rPr sz="1200" b="0"/>
-              <a:t>3. Aim and Motivation</a:t>
-            </a:r>
-          </a:p>
-          <a:p>
-            <a:pPr/>
-            <a:r>
-              <a:rPr sz="1200" b="0"/>
-              <a:t>4. Research Questions</a:t>
-            </a:r>
-          </a:p>
-          <a:p>
-            <a:pPr/>
-            <a:r>
-              <a:rPr sz="1200" b="0"/>
-              <a:t>5. Title Justification</a:t>
-            </a:r>
-          </a:p>
-          <a:p>
-            <a:pPr/>
-            <a:r>
-              <a:rPr sz="1200" b="0"/>
-              <a:t>6. Objectives</a:t>
-            </a:r>
-          </a:p>
-          <a:p>
-            <a:pPr/>
-            <a:r>
-              <a:rPr sz="1200" b="0"/>
-              <a:t>7. Scope</a:t>
-            </a:r>
-          </a:p>
-          <a:p>
-            <a:pPr/>
-            <a:r>
-              <a:rPr sz="1200" b="0"/>
-              <a:t>8. Timeline Chart</a:t>
-            </a:r>
-          </a:p>
-          <a:p>
-            <a:pPr/>
-            <a:r>
-              <a:rPr sz="1200" b="0"/>
-              <a:t>9. Introduction</a:t>
-            </a:r>
-          </a:p>
-          <a:p>
-            <a:pPr/>
-            <a:r>
-              <a:rPr sz="1200" b="0"/>
-              <a:t>10. Study on Existing Technologies</a:t>
-            </a:r>
-          </a:p>
-          <a:p>
-            <a:pPr/>
-            <a:r>
-              <a:rPr sz="1200" b="0"/>
-              <a:t>11. Gap Analysis</a:t>
-            </a:r>
-          </a:p>
-          <a:p>
-            <a:pPr/>
-            <a:r>
-              <a:rPr sz="1200" b="0"/>
-              <a:t>12. SDLC Model</a:t>
-            </a:r>
-          </a:p>
-          <a:p>
-            <a:pPr/>
-            <a:r>
-              <a:rPr sz="1200" b="0"/>
-              <a:t>13. UML Diagrams</a:t>
-            </a:r>
-          </a:p>
-          <a:p>
-            <a:pPr/>
-            <a:r>
-              <a:rPr sz="1200" b="0"/>
-              <a:t>14. Functional and Non-Functional Requirements</a:t>
-            </a:r>
-          </a:p>
-          <a:p>
-            <a:pPr/>
-            <a:r>
-              <a:rPr sz="1200" b="0"/>
-              <a:t>15. Data Collection</a:t>
-            </a:r>
-          </a:p>
-          <a:p>
-            <a:pPr/>
-            <a:r>
-              <a:rPr sz="1200" b="0"/>
-              <a:t>16. Data Preparation</a:t>
-            </a:r>
-          </a:p>
-          <a:p>
-            <a:pPr/>
-            <a:r>
-              <a:rPr sz="1200" b="0"/>
-              <a:t>17. Proposed System Architecture</a:t>
-            </a:r>
-          </a:p>
-          <a:p>
-            <a:pPr/>
-            <a:r>
-              <a:rPr sz="1200" b="0"/>
-              <a:t>18. Experimental Setup and Results</a:t>
-            </a:r>
-          </a:p>
-          <a:p>
-            <a:pPr/>
-            <a:r>
-              <a:rPr sz="1200" b="0"/>
-              <a:t>19. Project Outcomes</a:t>
-            </a:r>
-          </a:p>
-          <a:p>
-            <a:pPr/>
-            <a:r>
-              <a:rPr sz="1200" b="0"/>
-              <a:t>20. Conclusion and Future Work</a:t>
-            </a:r>
-          </a:p>
-        </p:txBody>
-      </p:sp>
-      <p:sp>
-        <p:nvSpPr>
-          <p:cNvPr id="6" name="Slide Number Placeholder 5">
-            <a:extLst>
-              <a:ext uri="{FF2B5EF4-FFF2-40B4-BE49-F238E27FC236}">
-                <a16:creationId xmlns:a16="http://schemas.microsoft.com/office/drawing/2014/main" id="{971C3DE6-22F4-4655-E43D-E5183840B449}"/>
-              </a:ext>
-            </a:extLst>
-          </p:cNvPr>
-          <p:cNvSpPr>
-            <a:spLocks noGrp="1"/>
-          </p:cNvSpPr>
-          <p:nvPr>
-            <p:ph type="sldNum" sz="quarter" idx="12"/>
-          </p:nvPr>
-        </p:nvSpPr>
-        <p:spPr/>
-        <p:txBody>
-          <a:bodyPr/>
-          <a:lstStyle/>
-          <a:p>
-            <a:fld id="{D90542D4-23E8-43E0-BA8E-C972DA1A005D}" type="slidenum">
-              <a:rPr lang="en-US" sz="1400" b="1" smtClean="0">
-                <a:solidFill>
-                  <a:schemeClr val="tx1"/>
-                </a:solidFill>
-                <a:latin typeface="Calisto MT" panose="02040603050505030304" pitchFamily="18" charset="0"/>
-              </a:rPr>
-              <a:pPr/>
-              <a:t>4</a:t>
-            </a:fld>
-            <a:endParaRPr lang="en-US" sz="1400" b="1" dirty="0">
-              <a:solidFill>
-                <a:schemeClr val="tx1"/>
-              </a:solidFill>
-              <a:latin typeface="Calisto MT" panose="02040603050505030304" pitchFamily="18" charset="0"/>
-            </a:endParaRPr>
-          </a:p>
-        </p:txBody>
-      </p:sp>
-    </p:spTree>
-    <p:extLst>
-      <p:ext uri="{BB962C8B-B14F-4D97-AF65-F5344CB8AC3E}">
-        <p14:creationId xmlns:p14="http://schemas.microsoft.com/office/powerpoint/2010/main" val="1397598054"/>
-      </p:ext>
-    </p:extLst>
-  </p:cSld>
-  <p:clrMapOvr>
-    <a:masterClrMapping/>
-  </p:clrMapOvr>
-</p:sld>
-</file>
-
-<file path=ppt/slides/slide5.xml><?xml version="1.0" encoding="utf-8"?>
 <p:sld xmlns:a="http://schemas.openxmlformats.org/drawingml/2006/main" xmlns:r="http://schemas.openxmlformats.org/officeDocument/2006/relationships" xmlns:p="http://schemas.openxmlformats.org/presentationml/2006/main">
   <p:cSld>
     <p:spTree>
@@ -7333,12 +7163,11 @@
           </a:xfrm>
         </p:spPr>
         <p:txBody>
-          <a:bodyPr numCol="1" wrap="square">
+          <a:bodyPr wrap="square" numCol="1">
             <a:normAutofit/>
           </a:bodyPr>
           <a:lstStyle/>
           <a:p>
-            <a:pPr/>
             <a:r>
               <a:rPr sz="1800" b="1"/>
               <a:t>Primary domain: Computational Genomics / Bioinformatics</a:t>
@@ -7359,7 +7188,6 @@
             </a:r>
           </a:p>
           <a:p>
-            <a:pPr/>
             <a:r>
               <a:rPr sz="1800" b="1"/>
               <a:t>Secondary domain: Machine Learning / Representation Learning</a:t>
@@ -7380,7 +7208,6 @@
             </a:r>
           </a:p>
           <a:p>
-            <a:pPr/>
             <a:r>
               <a:rPr sz="1800" b="1"/>
               <a:t>Where the two meet</a:t>
@@ -7428,7 +7255,7 @@
                 <a:latin typeface="Calisto MT" panose="02040603050505030304" pitchFamily="18" charset="0"/>
               </a:rPr>
               <a:pPr/>
-              <a:t>5</a:t>
+              <a:t>4</a:t>
             </a:fld>
             <a:endParaRPr lang="en-US" sz="1400" b="1" dirty="0">
               <a:solidFill>
@@ -7452,7 +7279,7 @@
 </p:sld>
 </file>
 
-<file path=ppt/slides/slide6.xml><?xml version="1.0" encoding="utf-8"?>
+<file path=ppt/slides/slide5.xml><?xml version="1.0" encoding="utf-8"?>
 <p:sld xmlns:a="http://schemas.openxmlformats.org/drawingml/2006/main" xmlns:r="http://schemas.openxmlformats.org/officeDocument/2006/relationships" xmlns:p="http://schemas.openxmlformats.org/presentationml/2006/main">
   <p:cSld>
     <p:spTree>
@@ -7540,12 +7367,11 @@
           </a:xfrm>
         </p:spPr>
         <p:txBody>
-          <a:bodyPr numCol="1" wrap="square">
+          <a:bodyPr wrap="square" numCol="1">
             <a:normAutofit/>
           </a:bodyPr>
           <a:lstStyle/>
           <a:p>
-            <a:pPr/>
             <a:r>
               <a:rPr sz="1800" b="1"/>
               <a:t>SDG 3 - Good Health and Well-being</a:t>
@@ -7566,7 +7392,6 @@
             </a:r>
           </a:p>
           <a:p>
-            <a:pPr/>
             <a:r>
               <a:rPr sz="1800" b="1"/>
               <a:t>SDG 9 - Industry, Innovation and Infrastructure</a:t>
@@ -7587,7 +7412,6 @@
             </a:r>
           </a:p>
           <a:p>
-            <a:pPr/>
             <a:r>
               <a:rPr sz="1800" b="1"/>
               <a:t>SDG 4 - Quality Education</a:t>
@@ -7608,6 +7432,204 @@
             <a:extLst>
               <a:ext uri="{FF2B5EF4-FFF2-40B4-BE49-F238E27FC236}">
                 <a16:creationId xmlns:a16="http://schemas.microsoft.com/office/drawing/2014/main" id="{EFCB90BE-2D81-5E43-3A1E-442D1D8B539F}"/>
+              </a:ext>
+            </a:extLst>
+          </p:cNvPr>
+          <p:cNvSpPr>
+            <a:spLocks noGrp="1"/>
+          </p:cNvSpPr>
+          <p:nvPr>
+            <p:ph type="sldNum" sz="quarter" idx="12"/>
+          </p:nvPr>
+        </p:nvSpPr>
+        <p:spPr/>
+        <p:txBody>
+          <a:bodyPr/>
+          <a:lstStyle/>
+          <a:p>
+            <a:fld id="{D90542D4-23E8-43E0-BA8E-C972DA1A005D}" type="slidenum">
+              <a:rPr lang="en-US" sz="1400" b="1" smtClean="0">
+                <a:solidFill>
+                  <a:schemeClr val="tx1"/>
+                </a:solidFill>
+                <a:latin typeface="Calisto MT" panose="02040603050505030304" pitchFamily="18" charset="0"/>
+              </a:rPr>
+              <a:pPr/>
+              <a:t>5</a:t>
+            </a:fld>
+            <a:endParaRPr lang="en-US" sz="1400" b="1" dirty="0">
+              <a:solidFill>
+                <a:schemeClr val="tx1"/>
+              </a:solidFill>
+              <a:latin typeface="Calisto MT" panose="02040603050505030304" pitchFamily="18" charset="0"/>
+            </a:endParaRPr>
+          </a:p>
+        </p:txBody>
+      </p:sp>
+    </p:spTree>
+    <p:extLst>
+      <p:ext uri="{BB962C8B-B14F-4D97-AF65-F5344CB8AC3E}">
+        <p14:creationId xmlns:p14="http://schemas.microsoft.com/office/powerpoint/2010/main" val="1997790384"/>
+      </p:ext>
+    </p:extLst>
+  </p:cSld>
+  <p:clrMapOvr>
+    <a:masterClrMapping/>
+  </p:clrMapOvr>
+</p:sld>
+</file>
+
+<file path=ppt/slides/slide6.xml><?xml version="1.0" encoding="utf-8"?>
+<p:sld xmlns:a="http://schemas.openxmlformats.org/drawingml/2006/main" xmlns:r="http://schemas.openxmlformats.org/officeDocument/2006/relationships" xmlns:p="http://schemas.openxmlformats.org/presentationml/2006/main">
+  <p:cSld>
+    <p:spTree>
+      <p:nvGrpSpPr>
+        <p:cNvPr id="1" name=""/>
+        <p:cNvGrpSpPr/>
+        <p:nvPr/>
+      </p:nvGrpSpPr>
+      <p:grpSpPr>
+        <a:xfrm>
+          <a:off x="0" y="0"/>
+          <a:ext cx="0" cy="0"/>
+          <a:chOff x="0" y="0"/>
+          <a:chExt cx="0" cy="0"/>
+        </a:xfrm>
+      </p:grpSpPr>
+      <p:sp>
+        <p:nvSpPr>
+          <p:cNvPr id="2" name="Title 1">
+            <a:extLst>
+              <a:ext uri="{FF2B5EF4-FFF2-40B4-BE49-F238E27FC236}">
+                <a16:creationId xmlns:a16="http://schemas.microsoft.com/office/drawing/2014/main" id="{5B738971-B764-E045-F92B-01E3322A0123}"/>
+              </a:ext>
+            </a:extLst>
+          </p:cNvPr>
+          <p:cNvSpPr>
+            <a:spLocks noGrp="1"/>
+          </p:cNvSpPr>
+          <p:nvPr>
+            <p:ph type="title"/>
+          </p:nvPr>
+        </p:nvSpPr>
+        <p:spPr>
+          <a:xfrm>
+            <a:off x="202676" y="120029"/>
+            <a:ext cx="8738648" cy="747237"/>
+          </a:xfrm>
+        </p:spPr>
+        <p:txBody>
+          <a:bodyPr>
+            <a:noAutofit/>
+          </a:bodyPr>
+          <a:lstStyle/>
+          <a:p>
+            <a:r>
+              <a:rPr lang="en-US" sz="3000" b="1" dirty="0">
+                <a:solidFill>
+                  <a:schemeClr val="accent2">
+                    <a:lumMod val="50000"/>
+                  </a:schemeClr>
+                </a:solidFill>
+                <a:latin typeface="Calisto MT" panose="02040603050505030304" pitchFamily="18" charset="0"/>
+              </a:rPr>
+              <a:t>3. Aim and Motivation</a:t>
+            </a:r>
+          </a:p>
+        </p:txBody>
+      </p:sp>
+      <p:sp>
+        <p:nvSpPr>
+          <p:cNvPr id="3" name="Content Placeholder 2">
+            <a:extLst>
+              <a:ext uri="{FF2B5EF4-FFF2-40B4-BE49-F238E27FC236}">
+                <a16:creationId xmlns:a16="http://schemas.microsoft.com/office/drawing/2014/main" id="{E5D502BE-F636-7D1D-85F0-BAFFD3E05E1C}"/>
+              </a:ext>
+            </a:extLst>
+          </p:cNvPr>
+          <p:cNvSpPr>
+            <a:spLocks noGrp="1"/>
+          </p:cNvSpPr>
+          <p:nvPr>
+            <p:ph idx="1"/>
+          </p:nvPr>
+        </p:nvSpPr>
+        <p:spPr>
+          <a:xfrm>
+            <a:off x="358218" y="867265"/>
+            <a:ext cx="8314441" cy="5870705"/>
+          </a:xfrm>
+        </p:spPr>
+        <p:txBody>
+          <a:bodyPr wrap="square" numCol="1">
+            <a:normAutofit/>
+          </a:bodyPr>
+          <a:lstStyle/>
+          <a:p>
+            <a:r>
+              <a:rPr sz="1600" b="1"/>
+              <a:t>Aim</a:t>
+            </a:r>
+          </a:p>
+          <a:p>
+            <a:pPr lvl="1"/>
+            <a:r>
+              <a:rPr sz="1400" b="0"/>
+              <a:t>Develop and evaluate a genomic representation model trained from scratch in which Hi-C contact information directly biases how a DNA sequence encoder exchanges information across distant genomic regions during self-supervised pretraining.</a:t>
+            </a:r>
+          </a:p>
+          <a:p>
+            <a:r>
+              <a:rPr sz="1600" b="1"/>
+              <a:t>Motivation</a:t>
+            </a:r>
+          </a:p>
+          <a:p>
+            <a:pPr lvl="1"/>
+            <a:r>
+              <a:rPr sz="1400" b="0"/>
+              <a:t>Sequence-only models must infer long-range regulatory relationships from sequence alone, though those relationships have already been measured experimentally</a:t>
+            </a:r>
+          </a:p>
+          <a:p>
+            <a:pPr lvl="1"/>
+            <a:r>
+              <a:rPr sz="1400" b="0"/>
+              <a:t>Existing 3D-genome models either predict Hi-C from sequence, represent Hi-C maps themselves, or align a frozen encoder to Hi-C embeddings after the fact</a:t>
+            </a:r>
+          </a:p>
+          <a:p>
+            <a:pPr lvl="1"/>
+            <a:r>
+              <a:rPr sz="1400" b="0"/>
+              <a:t>None lets the measured contact map decide which distal windows communicate while the representation is being learned</a:t>
+            </a:r>
+          </a:p>
+          <a:p>
+            <a:r>
+              <a:rPr sz="1600" b="1"/>
+              <a:t>The bet</a:t>
+            </a:r>
+          </a:p>
+          <a:p>
+            <a:pPr lvl="2"/>
+            <a:r>
+              <a:rPr sz="1200" b="0">
+                <a:solidFill>
+                  <a:srgbClr val="595959"/>
+                </a:solidFill>
+              </a:rPr>
+              <a:t>If real contacts carry information a sequence model cannot recover alone, conditioning on them should beat a matched model given shuffled contacts. If it does not, that null is itself a result about the limits of the signal.</a:t>
+            </a:r>
+          </a:p>
+        </p:txBody>
+      </p:sp>
+      <p:sp>
+        <p:nvSpPr>
+          <p:cNvPr id="7" name="Slide Number Placeholder 6">
+            <a:extLst>
+              <a:ext uri="{FF2B5EF4-FFF2-40B4-BE49-F238E27FC236}">
+                <a16:creationId xmlns:a16="http://schemas.microsoft.com/office/drawing/2014/main" id="{14F45621-8939-04E9-03B4-11AF180D5862}"/>
               </a:ext>
             </a:extLst>
           </p:cNvPr>
@@ -7645,7 +7667,7 @@
     </p:spTree>
     <p:extLst>
       <p:ext uri="{BB962C8B-B14F-4D97-AF65-F5344CB8AC3E}">
-        <p14:creationId xmlns:p14="http://schemas.microsoft.com/office/powerpoint/2010/main" val="1997790384"/>
+        <p14:creationId xmlns:p14="http://schemas.microsoft.com/office/powerpoint/2010/main" val="3338637167"/>
       </p:ext>
     </p:extLst>
   </p:cSld>
@@ -7690,8 +7712,8 @@
         </p:nvSpPr>
         <p:spPr>
           <a:xfrm>
-            <a:off x="202676" y="120029"/>
-            <a:ext cx="8738648" cy="747237"/>
+            <a:off x="202676" y="71961"/>
+            <a:ext cx="8738648" cy="634115"/>
           </a:xfrm>
         </p:spPr>
         <p:txBody>
@@ -7709,7 +7731,7 @@
                 </a:solidFill>
                 <a:latin typeface="Calisto MT" panose="02040603050505030304" pitchFamily="18" charset="0"/>
               </a:rPr>
-              <a:t>3. Aim and Motivation</a:t>
+              <a:t>4. Research Questions</a:t>
             </a:r>
           </a:p>
         </p:txBody>
@@ -7732,73 +7754,78 @@
         </p:nvSpPr>
         <p:spPr>
           <a:xfrm>
-            <a:off x="358218" y="867265"/>
-            <a:ext cx="8314441" cy="5870705"/>
+            <a:off x="273377" y="631596"/>
+            <a:ext cx="8578391" cy="6106375"/>
           </a:xfrm>
         </p:spPr>
         <p:txBody>
-          <a:bodyPr numCol="1" wrap="square">
+          <a:bodyPr wrap="square" numCol="1">
             <a:normAutofit/>
           </a:bodyPr>
           <a:lstStyle/>
           <a:p>
-            <a:pPr/>
-            <a:r>
-              <a:rPr sz="1600" b="1"/>
-              <a:t>Aim</a:t>
+            <a:r>
+              <a:rPr sz="1700" b="1"/>
+              <a:t>RQ1 - Does structural conditioning help at all?</a:t>
             </a:r>
           </a:p>
           <a:p>
             <a:pPr lvl="1"/>
             <a:r>
-              <a:rPr sz="1400" b="0"/>
-              <a:t>Develop and evaluate a genomic representation model trained from scratch in which Hi-C contact information directly biases how a DNA sequence encoder exchanges information across distant genomic regions during self-supervised pretraining.</a:t>
-            </a:r>
-          </a:p>
-          <a:p>
-            <a:pPr/>
-            <a:r>
-              <a:rPr sz="1600" b="1"/>
-              <a:t>Motivation</a:t>
+              <a:rPr sz="1500" b="0"/>
+              <a:t>Does biasing attention with measured Hi-C improve held-out chromosome contact prediction over a matched sequence-only encoder?</a:t>
+            </a:r>
+          </a:p>
+          <a:p>
+            <a:r>
+              <a:rPr sz="1700" b="1"/>
+              <a:t>RQ2 - Is the gain from real biology or from any extra signal?</a:t>
             </a:r>
           </a:p>
           <a:p>
             <a:pPr lvl="1"/>
             <a:r>
-              <a:rPr sz="1400" b="0"/>
-              <a:t>Sequence-only models must infer long-range regulatory relationships from sequence alone, though those relationships have already been measured experimentally</a:t>
+              <a:rPr sz="1500" b="0"/>
+              <a:t>Does it beat matched controls given shuffled Hi-C, distance-only edges and a random contact graph?</a:t>
+            </a:r>
+          </a:p>
+          <a:p>
+            <a:r>
+              <a:rPr sz="1700" b="1"/>
+              <a:t>RQ3 - Is conditioning better than fusion?</a:t>
             </a:r>
           </a:p>
           <a:p>
             <a:pPr lvl="1"/>
             <a:r>
-              <a:rPr sz="1400" b="0"/>
-              <a:t>Existing 3D-genome models either predict Hi-C from sequence, represent Hi-C maps themselves, or align a frozen encoder to Hi-C embeddings after the fact</a:t>
+              <a:rPr sz="1500" b="0"/>
+              <a:t>Does contact-biased attention inside the encoder beat late fusion applied after the sequence has been encoded?</a:t>
+            </a:r>
+          </a:p>
+          <a:p>
+            <a:r>
+              <a:rPr sz="1700" b="1"/>
+              <a:t>RQ4 - Is the structure retained in the sequence representation?</a:t>
             </a:r>
           </a:p>
           <a:p>
             <a:pPr lvl="1"/>
             <a:r>
-              <a:rPr sz="1400" b="0"/>
-              <a:t>None lets the measured contact map decide which distal windows communicate while the representation is being learned</a:t>
-            </a:r>
-          </a:p>
-          <a:p>
-            <a:pPr/>
-            <a:r>
-              <a:rPr sz="1600" b="1"/>
-              <a:t>The bet</a:t>
-            </a:r>
-          </a:p>
-          <a:p>
-            <a:pPr lvl="2"/>
-            <a:r>
-              <a:rPr sz="1200" b="0">
-                <a:solidFill>
-                  <a:srgbClr val="595959"/>
-                </a:solidFill>
-              </a:rPr>
-              <a:t>If real contacts carry information a sequence model cannot recover alone, conditioning on them should beat a matched model given shuffled contacts. If it does not, that null is itself a result about the limits of the signal.</a:t>
+              <a:rPr sz="1500" b="0"/>
+              <a:t>Does any improvement survive removing the contact graph at inference time?</a:t>
+            </a:r>
+          </a:p>
+          <a:p>
+            <a:r>
+              <a:rPr sz="1700" b="1"/>
+              <a:t>RQ5 - Does it transfer?</a:t>
+            </a:r>
+          </a:p>
+          <a:p>
+            <a:pPr lvl="1"/>
+            <a:r>
+              <a:rPr sz="1500" b="0"/>
+              <a:t>Does the pretrained encoder beat a from-scratch model on loop detection and enhancer-promoter linking, including on a held-out cell line?</a:t>
             </a:r>
           </a:p>
         </p:txBody>
@@ -7846,7 +7873,7 @@
     </p:spTree>
     <p:extLst>
       <p:ext uri="{BB962C8B-B14F-4D97-AF65-F5344CB8AC3E}">
-        <p14:creationId xmlns:p14="http://schemas.microsoft.com/office/powerpoint/2010/main" val="3338637167"/>
+        <p14:creationId xmlns:p14="http://schemas.microsoft.com/office/powerpoint/2010/main" val="2481146048"/>
       </p:ext>
     </p:extLst>
   </p:cSld>
@@ -7891,8 +7918,8 @@
         </p:nvSpPr>
         <p:spPr>
           <a:xfrm>
-            <a:off x="202676" y="71961"/>
-            <a:ext cx="8738648" cy="634115"/>
+            <a:off x="202676" y="120029"/>
+            <a:ext cx="8738648" cy="747237"/>
           </a:xfrm>
         </p:spPr>
         <p:txBody>
@@ -7910,7 +7937,7 @@
                 </a:solidFill>
                 <a:latin typeface="Calisto MT" panose="02040603050505030304" pitchFamily="18" charset="0"/>
               </a:rPr>
-              <a:t>4. Research Questions</a:t>
+              <a:t>5. Title Justification</a:t>
             </a:r>
           </a:p>
         </p:txBody>
@@ -7933,83 +7960,83 @@
         </p:nvSpPr>
         <p:spPr>
           <a:xfrm>
-            <a:off x="273377" y="631596"/>
-            <a:ext cx="8578391" cy="6106375"/>
+            <a:off x="358218" y="867265"/>
+            <a:ext cx="8314441" cy="5870705"/>
           </a:xfrm>
         </p:spPr>
         <p:txBody>
-          <a:bodyPr numCol="1" wrap="square">
+          <a:bodyPr wrap="square" numCol="1">
             <a:normAutofit/>
           </a:bodyPr>
           <a:lstStyle/>
           <a:p>
-            <a:pPr/>
             <a:r>
               <a:rPr sz="1700" b="1"/>
-              <a:t>RQ1 - Does structural conditioning help at all?</a:t>
+              <a:t>"ChromGraphFM"</a:t>
             </a:r>
           </a:p>
           <a:p>
             <a:pPr lvl="1"/>
             <a:r>
               <a:rPr sz="1500" b="0"/>
-              <a:t>Does biasing attention with measured Hi-C improve held-out chromosome contact prediction over a matched sequence-only encoder?</a:t>
-            </a:r>
-          </a:p>
-          <a:p>
-            <a:pPr/>
+              <a:t>Chrom - the object of study is chromatin, not sequence alone</a:t>
+            </a:r>
+          </a:p>
+          <a:p>
+            <a:pPr lvl="1"/>
+            <a:r>
+              <a:rPr sz="1500" b="0"/>
+              <a:t>Graph - a contact is a relation between two loci, not a pixel in an image</a:t>
+            </a:r>
+          </a:p>
+          <a:p>
+            <a:pPr lvl="1"/>
+            <a:r>
+              <a:rPr sz="1500" b="0"/>
+              <a:t>FM - the artefact is a pretrained encoder evaluated across several tasks</a:t>
+            </a:r>
+          </a:p>
+          <a:p>
             <a:r>
               <a:rPr sz="1700" b="1"/>
-              <a:t>RQ2 - Is the gain from real biology or from any extra signal?</a:t>
+              <a:t>"End-to-End"</a:t>
             </a:r>
           </a:p>
           <a:p>
             <a:pPr lvl="1"/>
             <a:r>
               <a:rPr sz="1500" b="0"/>
-              <a:t>Does it beat matched controls given shuffled Hi-C, distance-only edges and a random contact graph?</a:t>
-            </a:r>
-          </a:p>
-          <a:p>
-            <a:pPr/>
+              <a:t>Distinguishes this work from Evo2HiC, which distils a frozen Evo 2 backbone; here the sequence encoder trains from scratch under the structural objectives</a:t>
+            </a:r>
+          </a:p>
+          <a:p>
             <a:r>
               <a:rPr sz="1700" b="1"/>
-              <a:t>RQ3 - Is conditioning better than fusion?</a:t>
+              <a:t>"3D Chromatin-Conditioned"</a:t>
             </a:r>
           </a:p>
           <a:p>
             <a:pPr lvl="1"/>
             <a:r>
               <a:rPr sz="1500" b="0"/>
-              <a:t>Does contact-biased attention inside the encoder beat late fusion applied after the sequence has been encoded?</a:t>
-            </a:r>
-          </a:p>
-          <a:p>
-            <a:pPr/>
+              <a:t>Conditioned, not fused: the contact map alters attention inside the encoder at every block rather than being concatenated to its output</a:t>
+            </a:r>
+          </a:p>
+          <a:p>
             <a:r>
               <a:rPr sz="1700" b="1"/>
-              <a:t>RQ4 - Is the structure retained in the sequence representation?</a:t>
-            </a:r>
-          </a:p>
-          <a:p>
-            <a:pPr lvl="1"/>
-            <a:r>
-              <a:rPr sz="1500" b="0"/>
-              <a:t>Does any improvement survive removing the contact graph at inference time?</a:t>
-            </a:r>
-          </a:p>
-          <a:p>
-            <a:pPr/>
-            <a:r>
-              <a:rPr sz="1700" b="1"/>
-              <a:t>RQ5 - Does it transfer?</a:t>
-            </a:r>
-          </a:p>
-          <a:p>
-            <a:pPr lvl="1"/>
-            <a:r>
-              <a:rPr sz="1500" b="0"/>
-              <a:t>Does the pretrained encoder beat a from-scratch model on loop detection and enhancer-promoter linking, including on a held-out cell line?</a:t>
+              <a:t>A deliberate restraint on the word "Foundation"</a:t>
+            </a:r>
+          </a:p>
+          <a:p>
+            <a:pPr lvl="2"/>
+            <a:r>
+              <a:rPr sz="1300" b="0">
+                <a:solidFill>
+                  <a:srgbClr val="595959"/>
+                </a:solidFill>
+              </a:rPr>
+              <a:t>At 20-40M parameters this is a compact pretrained representation model, and the report will call it that unless multi-task transfer is demonstrated.</a:t>
             </a:r>
           </a:p>
         </p:txBody>
@@ -8057,7 +8084,7 @@
     </p:spTree>
     <p:extLst>
       <p:ext uri="{BB962C8B-B14F-4D97-AF65-F5344CB8AC3E}">
-        <p14:creationId xmlns:p14="http://schemas.microsoft.com/office/powerpoint/2010/main" val="2481146048"/>
+        <p14:creationId xmlns:p14="http://schemas.microsoft.com/office/powerpoint/2010/main" val="3066301131"/>
       </p:ext>
     </p:extLst>
   </p:cSld>
@@ -8121,7 +8148,7 @@
                 </a:solidFill>
                 <a:latin typeface="Calisto MT" panose="02040603050505030304" pitchFamily="18" charset="0"/>
               </a:rPr>
-              <a:t>5. Title Justification</a:t>
+              <a:t>6. Objectives</a:t>
             </a:r>
           </a:p>
         </p:txBody>
@@ -8149,82 +8176,86 @@
           </a:xfrm>
         </p:spPr>
         <p:txBody>
-          <a:bodyPr numCol="1" wrap="square">
+          <a:bodyPr wrap="square" numCol="1">
             <a:normAutofit/>
           </a:bodyPr>
           <a:lstStyle/>
           <a:p>
-            <a:pPr/>
-            <a:r>
-              <a:rPr sz="1700" b="1"/>
-              <a:t>"ChromGraphFM"</a:t>
+            <a:r>
+              <a:rPr sz="1600" b="1"/>
+              <a:t>O1 - Reproducible data foundation</a:t>
             </a:r>
           </a:p>
           <a:p>
             <a:pPr lvl="1"/>
             <a:r>
-              <a:rPr sz="1500" b="0"/>
-              <a:t>Chrom - the object of study is chromatin, not sequence alone</a:t>
+              <a:rPr sz="1400" b="0"/>
+              <a:t>Chromosome-split hg38 and Hi-C dataset at 5 kb, rebuildable from a tracked manifest</a:t>
+            </a:r>
+          </a:p>
+          <a:p>
+            <a:r>
+              <a:rPr sz="1600" b="1"/>
+              <a:t>O2 - Sparse contact graph construction</a:t>
             </a:r>
           </a:p>
           <a:p>
             <a:pPr lvl="1"/>
             <a:r>
-              <a:rPr sz="1500" b="0"/>
-              <a:t>Graph - a contact is a relation between two loci, not a pixel in an image</a:t>
+              <a:rPr sz="1400" b="0"/>
+              <a:t>640 kb regions as 128-node graphs, with target edges provably held out from the conditioning edges</a:t>
+            </a:r>
+          </a:p>
+          <a:p>
+            <a:r>
+              <a:rPr sz="1600" b="1"/>
+              <a:t>O3 - Contact-biased sequence encoder</a:t>
             </a:r>
           </a:p>
           <a:p>
             <a:pPr lvl="1"/>
             <a:r>
-              <a:rPr sz="1500" b="0"/>
-              <a:t>FM - the artefact is a pretrained encoder evaluated across several tasks</a:t>
-            </a:r>
-          </a:p>
-          <a:p>
-            <a:pPr/>
-            <a:r>
-              <a:rPr sz="1700" b="1"/>
-              <a:t>"End-to-End"</a:t>
+              <a:rPr sz="1400" b="0"/>
+              <a:t>Bi-directional Mamba local encoder, contact-biased attention, structure dropout</a:t>
+            </a:r>
+          </a:p>
+          <a:p>
+            <a:r>
+              <a:rPr sz="1600" b="1"/>
+              <a:t>O4 - Structure-aware pretraining</a:t>
             </a:r>
           </a:p>
           <a:p>
             <a:pPr lvl="1"/>
             <a:r>
-              <a:rPr sz="1500" b="0"/>
-              <a:t>Distinguishes this work from Evo2HiC, which distils a frozen Evo 2 backbone; here the sequence encoder trains from scratch under the structural objectives</a:t>
-            </a:r>
-          </a:p>
-          <a:p>
-            <a:pPr/>
-            <a:r>
-              <a:rPr sz="1700" b="1"/>
-              <a:t>"3D Chromatin-Conditioned"</a:t>
+              <a:rPr sz="1400" b="0"/>
+              <a:t>Masked DNA modelling, distance-matched contrastive learning, contact prediction</a:t>
+            </a:r>
+          </a:p>
+          <a:p>
+            <a:r>
+              <a:rPr sz="1600" b="1"/>
+              <a:t>O5 - Controlled evaluation</a:t>
             </a:r>
           </a:p>
           <a:p>
             <a:pPr lvl="1"/>
             <a:r>
-              <a:rPr sz="1500" b="0"/>
-              <a:t>Conditioned, not fused: the contact map alters attention inside the encoder at every block rather than being concatenated to its output</a:t>
-            </a:r>
-          </a:p>
-          <a:p>
-            <a:pPr/>
-            <a:r>
-              <a:rPr sz="1700" b="1"/>
-              <a:t>A deliberate restraint on the word "Foundation"</a:t>
-            </a:r>
-          </a:p>
-          <a:p>
-            <a:pPr lvl="2"/>
-            <a:r>
-              <a:rPr sz="1300" b="0">
-                <a:solidFill>
-                  <a:srgbClr val="595959"/>
-                </a:solidFill>
-              </a:rPr>
-              <a:t>At 20-40M parameters this is a compact pretrained representation model, and the report will call it that unless multi-task transfer is demonstrated.</a:t>
+              <a:rPr sz="1400" b="0"/>
+              <a:t>B0-B5 controls at matched parameters, data and steps; held-out chromosomes, held-out cell line, Hi-C-free inference</a:t>
+            </a:r>
+          </a:p>
+          <a:p>
+            <a:r>
+              <a:rPr sz="1600" b="1"/>
+              <a:t>O6 - Biological interpretation</a:t>
+            </a:r>
+          </a:p>
+          <a:p>
+            <a:pPr lvl="1"/>
+            <a:r>
+              <a:rPr sz="1400" b="0"/>
+              <a:t>Test whether high-attention contact anchors are enriched for CTCF motifs and overlap known loop anchors</a:t>
             </a:r>
           </a:p>
         </p:txBody>
@@ -8272,7 +8303,7 @@
     </p:spTree>
     <p:extLst>
       <p:ext uri="{BB962C8B-B14F-4D97-AF65-F5344CB8AC3E}">
-        <p14:creationId xmlns:p14="http://schemas.microsoft.com/office/powerpoint/2010/main" val="3066301131"/>
+        <p14:creationId xmlns:p14="http://schemas.microsoft.com/office/powerpoint/2010/main" val="441088729"/>
       </p:ext>
     </p:extLst>
   </p:cSld>

</xml_diff>